<commit_message>
docs: restyle presentation deck with branded theme
</commit_message>
<xml_diff>
--- a/presentation/Code-Challenge-2-Presentasi.pptx
+++ b/presentation/Code-Challenge-2-Presentasi.pptx
@@ -3509,6 +3509,14 @@
 <file path=ppt/slides/slide1.xml><?xml version="1.0" encoding="utf-8"?>
 <p:sld xmlns:a="http://schemas.openxmlformats.org/drawingml/2006/main" xmlns:p="http://schemas.openxmlformats.org/presentationml/2006/main" xmlns:r="http://schemas.openxmlformats.org/officeDocument/2006/relationships">
   <p:cSld>
+    <p:bg>
+      <p:bgPr>
+        <a:solidFill>
+          <a:srgbClr val="0F172A"/>
+        </a:solidFill>
+        <a:effectLst/>
+      </p:bgPr>
+    </p:bg>
     <p:spTree>
       <p:nvGrpSpPr>
         <p:cNvPr id="1" name=""/>
@@ -3570,6 +3578,166 @@
             <a:r>
               <a:t>2026</a:t>
             </a:r>
+          </a:p>
+        </p:txBody>
+      </p:sp>
+      <p:sp>
+        <p:nvSpPr>
+          <p:cNvPr id="4" name="Rectangle 3"/>
+          <p:cNvSpPr/>
+          <p:nvPr/>
+        </p:nvSpPr>
+        <p:spPr>
+          <a:xfrm>
+            <a:off x="0" y="0"/>
+            <a:ext cx="256032" cy="6858000"/>
+          </a:xfrm>
+          <a:prstGeom prst="rect">
+            <a:avLst/>
+          </a:prstGeom>
+          <a:solidFill>
+            <a:srgbClr val="6366F1"/>
+          </a:solidFill>
+        </p:spPr>
+        <p:style>
+          <a:lnRef idx="1">
+            <a:schemeClr val="accent1"/>
+          </a:lnRef>
+          <a:fillRef idx="3">
+            <a:schemeClr val="accent1"/>
+          </a:fillRef>
+          <a:effectRef idx="2">
+            <a:schemeClr val="accent1"/>
+          </a:effectRef>
+          <a:fontRef idx="minor">
+            <a:schemeClr val="lt1"/>
+          </a:fontRef>
+        </p:style>
+        <p:txBody>
+          <a:bodyPr rtlCol="0" anchor="ctr"/>
+          <a:lstStyle/>
+          <a:p>
+            <a:pPr algn="ctr"/>
+          </a:p>
+        </p:txBody>
+      </p:sp>
+      <p:sp>
+        <p:nvSpPr>
+          <p:cNvPr id="5" name="Rectangle 4"/>
+          <p:cNvSpPr/>
+          <p:nvPr/>
+        </p:nvSpPr>
+        <p:spPr>
+          <a:xfrm>
+            <a:off x="777240" y="3291840"/>
+            <a:ext cx="2194560" cy="73152"/>
+          </a:xfrm>
+          <a:prstGeom prst="rect">
+            <a:avLst/>
+          </a:prstGeom>
+          <a:solidFill>
+            <a:srgbClr val="8B5CF6"/>
+          </a:solidFill>
+        </p:spPr>
+        <p:style>
+          <a:lnRef idx="1">
+            <a:schemeClr val="accent1"/>
+          </a:lnRef>
+          <a:fillRef idx="3">
+            <a:schemeClr val="accent1"/>
+          </a:fillRef>
+          <a:effectRef idx="2">
+            <a:schemeClr val="accent1"/>
+          </a:effectRef>
+          <a:fontRef idx="minor">
+            <a:schemeClr val="lt1"/>
+          </a:fontRef>
+        </p:style>
+        <p:txBody>
+          <a:bodyPr rtlCol="0" anchor="ctr"/>
+          <a:lstStyle/>
+          <a:p>
+            <a:pPr algn="ctr"/>
+          </a:p>
+        </p:txBody>
+      </p:sp>
+      <p:sp>
+        <p:nvSpPr>
+          <p:cNvPr id="6" name="Oval 5"/>
+          <p:cNvSpPr/>
+          <p:nvPr/>
+        </p:nvSpPr>
+        <p:spPr>
+          <a:xfrm>
+            <a:off x="10241280" y="-1097280"/>
+            <a:ext cx="2926080" cy="2926080"/>
+          </a:xfrm>
+          <a:prstGeom prst="ellipse">
+            <a:avLst/>
+          </a:prstGeom>
+          <a:solidFill>
+            <a:srgbClr val="4F46E5"/>
+          </a:solidFill>
+        </p:spPr>
+        <p:style>
+          <a:lnRef idx="1">
+            <a:schemeClr val="accent1"/>
+          </a:lnRef>
+          <a:fillRef idx="3">
+            <a:schemeClr val="accent1"/>
+          </a:fillRef>
+          <a:effectRef idx="2">
+            <a:schemeClr val="accent1"/>
+          </a:effectRef>
+          <a:fontRef idx="minor">
+            <a:schemeClr val="lt1"/>
+          </a:fontRef>
+        </p:style>
+        <p:txBody>
+          <a:bodyPr rtlCol="0" anchor="ctr"/>
+          <a:lstStyle/>
+          <a:p>
+            <a:pPr algn="ctr"/>
+          </a:p>
+        </p:txBody>
+      </p:sp>
+      <p:sp>
+        <p:nvSpPr>
+          <p:cNvPr id="7" name="Oval 6"/>
+          <p:cNvSpPr/>
+          <p:nvPr/>
+        </p:nvSpPr>
+        <p:spPr>
+          <a:xfrm>
+            <a:off x="9692640" y="4754880"/>
+            <a:ext cx="2377440" cy="2377440"/>
+          </a:xfrm>
+          <a:prstGeom prst="ellipse">
+            <a:avLst/>
+          </a:prstGeom>
+          <a:solidFill>
+            <a:srgbClr val="7C3AED"/>
+          </a:solidFill>
+        </p:spPr>
+        <p:style>
+          <a:lnRef idx="1">
+            <a:schemeClr val="accent1"/>
+          </a:lnRef>
+          <a:fillRef idx="3">
+            <a:schemeClr val="accent1"/>
+          </a:fillRef>
+          <a:effectRef idx="2">
+            <a:schemeClr val="accent1"/>
+          </a:effectRef>
+          <a:fontRef idx="minor">
+            <a:schemeClr val="lt1"/>
+          </a:fontRef>
+        </p:style>
+        <p:txBody>
+          <a:bodyPr rtlCol="0" anchor="ctr"/>
+          <a:lstStyle/>
+          <a:p>
+            <a:pPr algn="ctr"/>
           </a:p>
         </p:txBody>
       </p:sp>
@@ -3584,6 +3752,14 @@
 <file path=ppt/slides/slide2.xml><?xml version="1.0" encoding="utf-8"?>
 <p:sld xmlns:a="http://schemas.openxmlformats.org/drawingml/2006/main" xmlns:p="http://schemas.openxmlformats.org/presentationml/2006/main" xmlns:r="http://schemas.openxmlformats.org/officeDocument/2006/relationships">
   <p:cSld>
+    <p:bg>
+      <p:bgPr>
+        <a:solidFill>
+          <a:srgbClr val="FFFFFF"/>
+        </a:solidFill>
+        <a:effectLst/>
+      </p:bgPr>
+    </p:bg>
     <p:spTree>
       <p:nvGrpSpPr>
         <p:cNvPr id="1" name=""/>
@@ -3629,28 +3805,44 @@
           <a:p>
             <a:pPr/>
             <a:r>
-              <a:rPr/>
+              <a:rPr>
+                <a:solidFill>
+                  <a:srgbClr val="334155"/>
+                </a:solidFill>
+              </a:rPr>
               <a:t>Avatar inisial (MD) berbingkai conic-gradient yang berputar otomatis (spin 4 detik).</a:t>
             </a:r>
           </a:p>
           <a:p>
             <a:pPr/>
             <a:r>
-              <a:rPr/>
+              <a:rPr>
+                <a:solidFill>
+                  <a:srgbClr val="334155"/>
+                </a:solidFill>
+              </a:rPr>
               <a:t>Glow pulsing lembut di belakang avatar (efek bernapas, 3 detik).</a:t>
             </a:r>
           </a:p>
           <a:p>
             <a:pPr/>
             <a:r>
-              <a:rPr/>
+              <a:rPr>
+                <a:solidFill>
+                  <a:srgbClr val="334155"/>
+                </a:solidFill>
+              </a:rPr>
               <a:t>Background SVG: pola dots + gradient mesh blob di 4 sudut.</a:t>
             </a:r>
           </a:p>
           <a:p>
             <a:pPr/>
             <a:r>
-              <a:rPr/>
+              <a:rPr>
+                <a:solidFill>
+                  <a:srgbClr val="334155"/>
+                </a:solidFill>
+              </a:rPr>
               <a:t>Menampilkan nama, job title, lokasi, dan bio singkat dari data profil.</a:t>
             </a:r>
           </a:p>
@@ -3658,20 +3850,60 @@
       </p:sp>
       <p:sp>
         <p:nvSpPr>
-          <p:cNvPr id="4" name="Rounded Rectangle 3"/>
+          <p:cNvPr id="4" name="Rectangle 3"/>
           <p:cNvSpPr/>
           <p:nvPr/>
         </p:nvSpPr>
         <p:spPr>
           <a:xfrm>
-            <a:off x="731520" y="5394960"/>
-            <a:ext cx="5212080" cy="1005840"/>
+            <a:off x="0" y="0"/>
+            <a:ext cx="256032" cy="6858000"/>
+          </a:xfrm>
+          <a:prstGeom prst="rect">
+            <a:avLst/>
+          </a:prstGeom>
+          <a:solidFill>
+            <a:srgbClr val="6366F1"/>
+          </a:solidFill>
+        </p:spPr>
+        <p:style>
+          <a:lnRef idx="1">
+            <a:schemeClr val="accent1"/>
+          </a:lnRef>
+          <a:fillRef idx="3">
+            <a:schemeClr val="accent1"/>
+          </a:fillRef>
+          <a:effectRef idx="2">
+            <a:schemeClr val="accent1"/>
+          </a:effectRef>
+          <a:fontRef idx="minor">
+            <a:schemeClr val="lt1"/>
+          </a:fontRef>
+        </p:style>
+        <p:txBody>
+          <a:bodyPr rtlCol="0" anchor="ctr"/>
+          <a:lstStyle/>
+          <a:p>
+            <a:pPr algn="ctr"/>
+          </a:p>
+        </p:txBody>
+      </p:sp>
+      <p:sp>
+        <p:nvSpPr>
+          <p:cNvPr id="5" name="Rounded Rectangle 4"/>
+          <p:cNvSpPr/>
+          <p:nvPr/>
+        </p:nvSpPr>
+        <p:spPr>
+          <a:xfrm>
+            <a:off x="731520" y="5440680"/>
+            <a:ext cx="5212080" cy="914400"/>
           </a:xfrm>
           <a:prstGeom prst="roundRect">
             <a:avLst/>
           </a:prstGeom>
           <a:solidFill>
-            <a:srgbClr val="E5E7EB"/>
+            <a:srgbClr val="EEF2FF"/>
           </a:solidFill>
         </p:spPr>
         <p:style>
@@ -3695,7 +3927,7 @@
             <a:r>
               <a:rPr>
                 <a:solidFill>
-                  <a:srgbClr val="374151"/>
+                  <a:srgbClr val="4338CA"/>
                 </a:solidFill>
               </a:rPr>
               <a:t>Desktop View — sisipkan screenshot</a:t>
@@ -3705,20 +3937,20 @@
       </p:sp>
       <p:sp>
         <p:nvSpPr>
-          <p:cNvPr id="5" name="Rounded Rectangle 4"/>
+          <p:cNvPr id="6" name="Rounded Rectangle 5"/>
           <p:cNvSpPr/>
           <p:nvPr/>
         </p:nvSpPr>
         <p:spPr>
           <a:xfrm>
-            <a:off x="6309360" y="5394960"/>
-            <a:ext cx="5212080" cy="1005840"/>
+            <a:off x="6263640" y="5440680"/>
+            <a:ext cx="5212080" cy="914400"/>
           </a:xfrm>
           <a:prstGeom prst="roundRect">
             <a:avLst/>
           </a:prstGeom>
           <a:solidFill>
-            <a:srgbClr val="E5E7EB"/>
+            <a:srgbClr val="EEF2FF"/>
           </a:solidFill>
         </p:spPr>
         <p:style>
@@ -3742,11 +3974,51 @@
             <a:r>
               <a:rPr>
                 <a:solidFill>
-                  <a:srgbClr val="374151"/>
+                  <a:srgbClr val="4338CA"/>
                 </a:solidFill>
               </a:rPr>
               <a:t>Mobile View — sisipkan screenshot</a:t>
             </a:r>
+          </a:p>
+        </p:txBody>
+      </p:sp>
+      <p:sp>
+        <p:nvSpPr>
+          <p:cNvPr id="7" name="Rectangle 6"/>
+          <p:cNvSpPr/>
+          <p:nvPr/>
+        </p:nvSpPr>
+        <p:spPr>
+          <a:xfrm>
+            <a:off x="731520" y="6446520"/>
+            <a:ext cx="10698480" cy="9144"/>
+          </a:xfrm>
+          <a:prstGeom prst="rect">
+            <a:avLst/>
+          </a:prstGeom>
+          <a:solidFill>
+            <a:srgbClr val="E2E8F0"/>
+          </a:solidFill>
+        </p:spPr>
+        <p:style>
+          <a:lnRef idx="1">
+            <a:schemeClr val="accent1"/>
+          </a:lnRef>
+          <a:fillRef idx="3">
+            <a:schemeClr val="accent1"/>
+          </a:fillRef>
+          <a:effectRef idx="2">
+            <a:schemeClr val="accent1"/>
+          </a:effectRef>
+          <a:fontRef idx="minor">
+            <a:schemeClr val="lt1"/>
+          </a:fontRef>
+        </p:style>
+        <p:txBody>
+          <a:bodyPr rtlCol="0" anchor="ctr"/>
+          <a:lstStyle/>
+          <a:p>
+            <a:pPr algn="ctr"/>
           </a:p>
         </p:txBody>
       </p:sp>
@@ -3761,6 +4033,14 @@
 <file path=ppt/slides/slide3.xml><?xml version="1.0" encoding="utf-8"?>
 <p:sld xmlns:a="http://schemas.openxmlformats.org/drawingml/2006/main" xmlns:p="http://schemas.openxmlformats.org/presentationml/2006/main" xmlns:r="http://schemas.openxmlformats.org/officeDocument/2006/relationships">
   <p:cSld>
+    <p:bg>
+      <p:bgPr>
+        <a:solidFill>
+          <a:srgbClr val="FFFFFF"/>
+        </a:solidFill>
+        <a:effectLst/>
+      </p:bgPr>
+    </p:bg>
     <p:spTree>
       <p:nvGrpSpPr>
         <p:cNvPr id="1" name=""/>
@@ -3806,28 +4086,44 @@
           <a:p>
             <a:pPr/>
             <a:r>
-              <a:rPr/>
+              <a:rPr>
+                <a:solidFill>
+                  <a:srgbClr val="334155"/>
+                </a:solidFill>
+              </a:rPr>
               <a:t>Navbar sticky dengan backdrop-blur agar tetap terlihat saat scroll.</a:t>
             </a:r>
           </a:p>
           <a:p>
             <a:pPr/>
             <a:r>
-              <a:rPr/>
+              <a:rPr>
+                <a:solidFill>
+                  <a:srgbClr val="334155"/>
+                </a:solidFill>
+              </a:rPr>
               <a:t>Underline beranimasi muncul saat hover dan menetap pada menu aktif.</a:t>
             </a:r>
           </a:p>
           <a:p>
             <a:pPr/>
             <a:r>
-              <a:rPr/>
+              <a:rPr>
+                <a:solidFill>
+                  <a:srgbClr val="334155"/>
+                </a:solidFill>
+              </a:rPr>
               <a:t>Hook useScrollSpy memakai IntersectionObserver untuk mendeteksi section yang sedang dilihat.</a:t>
             </a:r>
           </a:p>
           <a:p>
             <a:pPr/>
             <a:r>
-              <a:rPr/>
+              <a:rPr>
+                <a:solidFill>
+                  <a:srgbClr val="334155"/>
+                </a:solidFill>
+              </a:rPr>
               <a:t>Smooth scrolling antar section (CSS scroll-behavior: smooth + scroll-margin-top).</a:t>
             </a:r>
           </a:p>
@@ -3835,20 +4131,60 @@
       </p:sp>
       <p:sp>
         <p:nvSpPr>
-          <p:cNvPr id="4" name="Rounded Rectangle 3"/>
+          <p:cNvPr id="4" name="Rectangle 3"/>
           <p:cNvSpPr/>
           <p:nvPr/>
         </p:nvSpPr>
         <p:spPr>
           <a:xfrm>
-            <a:off x="731520" y="5394960"/>
-            <a:ext cx="5212080" cy="1005840"/>
+            <a:off x="0" y="0"/>
+            <a:ext cx="256032" cy="6858000"/>
+          </a:xfrm>
+          <a:prstGeom prst="rect">
+            <a:avLst/>
+          </a:prstGeom>
+          <a:solidFill>
+            <a:srgbClr val="6366F1"/>
+          </a:solidFill>
+        </p:spPr>
+        <p:style>
+          <a:lnRef idx="1">
+            <a:schemeClr val="accent1"/>
+          </a:lnRef>
+          <a:fillRef idx="3">
+            <a:schemeClr val="accent1"/>
+          </a:fillRef>
+          <a:effectRef idx="2">
+            <a:schemeClr val="accent1"/>
+          </a:effectRef>
+          <a:fontRef idx="minor">
+            <a:schemeClr val="lt1"/>
+          </a:fontRef>
+        </p:style>
+        <p:txBody>
+          <a:bodyPr rtlCol="0" anchor="ctr"/>
+          <a:lstStyle/>
+          <a:p>
+            <a:pPr algn="ctr"/>
+          </a:p>
+        </p:txBody>
+      </p:sp>
+      <p:sp>
+        <p:nvSpPr>
+          <p:cNvPr id="5" name="Rounded Rectangle 4"/>
+          <p:cNvSpPr/>
+          <p:nvPr/>
+        </p:nvSpPr>
+        <p:spPr>
+          <a:xfrm>
+            <a:off x="731520" y="5440680"/>
+            <a:ext cx="5212080" cy="914400"/>
           </a:xfrm>
           <a:prstGeom prst="roundRect">
             <a:avLst/>
           </a:prstGeom>
           <a:solidFill>
-            <a:srgbClr val="E5E7EB"/>
+            <a:srgbClr val="EEF2FF"/>
           </a:solidFill>
         </p:spPr>
         <p:style>
@@ -3872,7 +4208,7 @@
             <a:r>
               <a:rPr>
                 <a:solidFill>
-                  <a:srgbClr val="374151"/>
+                  <a:srgbClr val="4338CA"/>
                 </a:solidFill>
               </a:rPr>
               <a:t>Desktop View — sisipkan screenshot</a:t>
@@ -3882,20 +4218,20 @@
       </p:sp>
       <p:sp>
         <p:nvSpPr>
-          <p:cNvPr id="5" name="Rounded Rectangle 4"/>
+          <p:cNvPr id="6" name="Rounded Rectangle 5"/>
           <p:cNvSpPr/>
           <p:nvPr/>
         </p:nvSpPr>
         <p:spPr>
           <a:xfrm>
-            <a:off x="6309360" y="5394960"/>
-            <a:ext cx="5212080" cy="1005840"/>
+            <a:off x="6263640" y="5440680"/>
+            <a:ext cx="5212080" cy="914400"/>
           </a:xfrm>
           <a:prstGeom prst="roundRect">
             <a:avLst/>
           </a:prstGeom>
           <a:solidFill>
-            <a:srgbClr val="E5E7EB"/>
+            <a:srgbClr val="EEF2FF"/>
           </a:solidFill>
         </p:spPr>
         <p:style>
@@ -3919,11 +4255,51 @@
             <a:r>
               <a:rPr>
                 <a:solidFill>
-                  <a:srgbClr val="374151"/>
+                  <a:srgbClr val="4338CA"/>
                 </a:solidFill>
               </a:rPr>
               <a:t>Mobile View — sisipkan screenshot</a:t>
             </a:r>
+          </a:p>
+        </p:txBody>
+      </p:sp>
+      <p:sp>
+        <p:nvSpPr>
+          <p:cNvPr id="7" name="Rectangle 6"/>
+          <p:cNvSpPr/>
+          <p:nvPr/>
+        </p:nvSpPr>
+        <p:spPr>
+          <a:xfrm>
+            <a:off x="731520" y="6446520"/>
+            <a:ext cx="10698480" cy="9144"/>
+          </a:xfrm>
+          <a:prstGeom prst="rect">
+            <a:avLst/>
+          </a:prstGeom>
+          <a:solidFill>
+            <a:srgbClr val="E2E8F0"/>
+          </a:solidFill>
+        </p:spPr>
+        <p:style>
+          <a:lnRef idx="1">
+            <a:schemeClr val="accent1"/>
+          </a:lnRef>
+          <a:fillRef idx="3">
+            <a:schemeClr val="accent1"/>
+          </a:fillRef>
+          <a:effectRef idx="2">
+            <a:schemeClr val="accent1"/>
+          </a:effectRef>
+          <a:fontRef idx="minor">
+            <a:schemeClr val="lt1"/>
+          </a:fontRef>
+        </p:style>
+        <p:txBody>
+          <a:bodyPr rtlCol="0" anchor="ctr"/>
+          <a:lstStyle/>
+          <a:p>
+            <a:pPr algn="ctr"/>
           </a:p>
         </p:txBody>
       </p:sp>
@@ -3938,6 +4314,14 @@
 <file path=ppt/slides/slide4.xml><?xml version="1.0" encoding="utf-8"?>
 <p:sld xmlns:a="http://schemas.openxmlformats.org/drawingml/2006/main" xmlns:p="http://schemas.openxmlformats.org/presentationml/2006/main" xmlns:r="http://schemas.openxmlformats.org/officeDocument/2006/relationships">
   <p:cSld>
+    <p:bg>
+      <p:bgPr>
+        <a:solidFill>
+          <a:srgbClr val="FFFFFF"/>
+        </a:solidFill>
+        <a:effectLst/>
+      </p:bgPr>
+    </p:bg>
     <p:spTree>
       <p:nvGrpSpPr>
         <p:cNvPr id="1" name=""/>
@@ -3983,28 +4367,44 @@
           <a:p>
             <a:pPr/>
             <a:r>
-              <a:rPr/>
+              <a:rPr>
+                <a:solidFill>
+                  <a:srgbClr val="334155"/>
+                </a:solidFill>
+              </a:rPr>
               <a:t>Skills, Experience, dan Testimonials memakai kartu gradient berwarna (indigo, sky, teal, fuchsia).</a:t>
             </a:r>
           </a:p>
           <a:p>
             <a:pPr/>
             <a:r>
-              <a:rPr/>
+              <a:rPr>
+                <a:solidFill>
+                  <a:srgbClr val="334155"/>
+                </a:solidFill>
+              </a:rPr>
               <a:t>Hover: kartu terangkat (translate-y) + shadow membesar.</a:t>
             </a:r>
           </a:p>
           <a:p>
             <a:pPr/>
             <a:r>
-              <a:rPr/>
+              <a:rPr>
+                <a:solidFill>
+                  <a:srgbClr val="334155"/>
+                </a:solidFill>
+              </a:rPr>
               <a:t>Background kartu berubah warna saat hover (section Skills).</a:t>
             </a:r>
           </a:p>
           <a:p>
             <a:pPr/>
             <a:r>
-              <a:rPr/>
+              <a:rPr>
+                <a:solidFill>
+                  <a:srgbClr val="334155"/>
+                </a:solidFill>
+              </a:rPr>
               <a:t>Light bloom + elemen dekoratif muncul saat hover di setiap kartu.</a:t>
             </a:r>
           </a:p>
@@ -4012,20 +4412,60 @@
       </p:sp>
       <p:sp>
         <p:nvSpPr>
-          <p:cNvPr id="4" name="Rounded Rectangle 3"/>
+          <p:cNvPr id="4" name="Rectangle 3"/>
           <p:cNvSpPr/>
           <p:nvPr/>
         </p:nvSpPr>
         <p:spPr>
           <a:xfrm>
-            <a:off x="731520" y="5394960"/>
-            <a:ext cx="5212080" cy="1005840"/>
+            <a:off x="0" y="0"/>
+            <a:ext cx="256032" cy="6858000"/>
+          </a:xfrm>
+          <a:prstGeom prst="rect">
+            <a:avLst/>
+          </a:prstGeom>
+          <a:solidFill>
+            <a:srgbClr val="6366F1"/>
+          </a:solidFill>
+        </p:spPr>
+        <p:style>
+          <a:lnRef idx="1">
+            <a:schemeClr val="accent1"/>
+          </a:lnRef>
+          <a:fillRef idx="3">
+            <a:schemeClr val="accent1"/>
+          </a:fillRef>
+          <a:effectRef idx="2">
+            <a:schemeClr val="accent1"/>
+          </a:effectRef>
+          <a:fontRef idx="minor">
+            <a:schemeClr val="lt1"/>
+          </a:fontRef>
+        </p:style>
+        <p:txBody>
+          <a:bodyPr rtlCol="0" anchor="ctr"/>
+          <a:lstStyle/>
+          <a:p>
+            <a:pPr algn="ctr"/>
+          </a:p>
+        </p:txBody>
+      </p:sp>
+      <p:sp>
+        <p:nvSpPr>
+          <p:cNvPr id="5" name="Rounded Rectangle 4"/>
+          <p:cNvSpPr/>
+          <p:nvPr/>
+        </p:nvSpPr>
+        <p:spPr>
+          <a:xfrm>
+            <a:off x="731520" y="5440680"/>
+            <a:ext cx="5212080" cy="914400"/>
           </a:xfrm>
           <a:prstGeom prst="roundRect">
             <a:avLst/>
           </a:prstGeom>
           <a:solidFill>
-            <a:srgbClr val="E5E7EB"/>
+            <a:srgbClr val="EEF2FF"/>
           </a:solidFill>
         </p:spPr>
         <p:style>
@@ -4049,7 +4489,7 @@
             <a:r>
               <a:rPr>
                 <a:solidFill>
-                  <a:srgbClr val="374151"/>
+                  <a:srgbClr val="4338CA"/>
                 </a:solidFill>
               </a:rPr>
               <a:t>Desktop View — sisipkan screenshot</a:t>
@@ -4059,20 +4499,20 @@
       </p:sp>
       <p:sp>
         <p:nvSpPr>
-          <p:cNvPr id="5" name="Rounded Rectangle 4"/>
+          <p:cNvPr id="6" name="Rounded Rectangle 5"/>
           <p:cNvSpPr/>
           <p:nvPr/>
         </p:nvSpPr>
         <p:spPr>
           <a:xfrm>
-            <a:off x="6309360" y="5394960"/>
-            <a:ext cx="5212080" cy="1005840"/>
+            <a:off x="6263640" y="5440680"/>
+            <a:ext cx="5212080" cy="914400"/>
           </a:xfrm>
           <a:prstGeom prst="roundRect">
             <a:avLst/>
           </a:prstGeom>
           <a:solidFill>
-            <a:srgbClr val="E5E7EB"/>
+            <a:srgbClr val="EEF2FF"/>
           </a:solidFill>
         </p:spPr>
         <p:style>
@@ -4096,11 +4536,51 @@
             <a:r>
               <a:rPr>
                 <a:solidFill>
-                  <a:srgbClr val="374151"/>
+                  <a:srgbClr val="4338CA"/>
                 </a:solidFill>
               </a:rPr>
               <a:t>Mobile View — sisipkan screenshot</a:t>
             </a:r>
+          </a:p>
+        </p:txBody>
+      </p:sp>
+      <p:sp>
+        <p:nvSpPr>
+          <p:cNvPr id="7" name="Rectangle 6"/>
+          <p:cNvSpPr/>
+          <p:nvPr/>
+        </p:nvSpPr>
+        <p:spPr>
+          <a:xfrm>
+            <a:off x="731520" y="6446520"/>
+            <a:ext cx="10698480" cy="9144"/>
+          </a:xfrm>
+          <a:prstGeom prst="rect">
+            <a:avLst/>
+          </a:prstGeom>
+          <a:solidFill>
+            <a:srgbClr val="E2E8F0"/>
+          </a:solidFill>
+        </p:spPr>
+        <p:style>
+          <a:lnRef idx="1">
+            <a:schemeClr val="accent1"/>
+          </a:lnRef>
+          <a:fillRef idx="3">
+            <a:schemeClr val="accent1"/>
+          </a:fillRef>
+          <a:effectRef idx="2">
+            <a:schemeClr val="accent1"/>
+          </a:effectRef>
+          <a:fontRef idx="minor">
+            <a:schemeClr val="lt1"/>
+          </a:fontRef>
+        </p:style>
+        <p:txBody>
+          <a:bodyPr rtlCol="0" anchor="ctr"/>
+          <a:lstStyle/>
+          <a:p>
+            <a:pPr algn="ctr"/>
           </a:p>
         </p:txBody>
       </p:sp>
@@ -4115,6 +4595,14 @@
 <file path=ppt/slides/slide5.xml><?xml version="1.0" encoding="utf-8"?>
 <p:sld xmlns:a="http://schemas.openxmlformats.org/drawingml/2006/main" xmlns:p="http://schemas.openxmlformats.org/presentationml/2006/main" xmlns:r="http://schemas.openxmlformats.org/officeDocument/2006/relationships">
   <p:cSld>
+    <p:bg>
+      <p:bgPr>
+        <a:solidFill>
+          <a:srgbClr val="FFFFFF"/>
+        </a:solidFill>
+        <a:effectLst/>
+      </p:bgPr>
+    </p:bg>
     <p:spTree>
       <p:nvGrpSpPr>
         <p:cNvPr id="1" name=""/>
@@ -4160,28 +4648,44 @@
           <a:p>
             <a:pPr/>
             <a:r>
-              <a:rPr/>
+              <a:rPr>
+                <a:solidFill>
+                  <a:srgbClr val="334155"/>
+                </a:solidFill>
+              </a:rPr>
               <a:t>Single-page application (React Router) dengan SPA fallback di Vercel.</a:t>
             </a:r>
           </a:p>
           <a:p>
             <a:pPr/>
             <a:r>
-              <a:rPr/>
+              <a:rPr>
+                <a:solidFill>
+                  <a:srgbClr val="334155"/>
+                </a:solidFill>
+              </a:rPr>
               <a:t>Mobile-first memakai Tailwind responsive breakpoints.</a:t>
             </a:r>
           </a:p>
           <a:p>
             <a:pPr/>
             <a:r>
-              <a:rPr/>
+              <a:rPr>
+                <a:solidFill>
+                  <a:srgbClr val="334155"/>
+                </a:solidFill>
+              </a:rPr>
               <a:t>Aset gambar minim: avatar &amp; background berbasis CSS/SVG, tanpa bitmap besar.</a:t>
             </a:r>
           </a:p>
           <a:p>
             <a:pPr/>
             <a:r>
-              <a:rPr/>
+              <a:rPr>
+                <a:solidFill>
+                  <a:srgbClr val="334155"/>
+                </a:solidFill>
+              </a:rPr>
               <a:t>Meta tags, robots.txt, dan SEO dasar pada index.html.</a:t>
             </a:r>
           </a:p>
@@ -4189,20 +4693,60 @@
       </p:sp>
       <p:sp>
         <p:nvSpPr>
-          <p:cNvPr id="4" name="Rounded Rectangle 3"/>
+          <p:cNvPr id="4" name="Rectangle 3"/>
           <p:cNvSpPr/>
           <p:nvPr/>
         </p:nvSpPr>
         <p:spPr>
           <a:xfrm>
-            <a:off x="731520" y="5394960"/>
-            <a:ext cx="5212080" cy="1005840"/>
+            <a:off x="0" y="0"/>
+            <a:ext cx="256032" cy="6858000"/>
+          </a:xfrm>
+          <a:prstGeom prst="rect">
+            <a:avLst/>
+          </a:prstGeom>
+          <a:solidFill>
+            <a:srgbClr val="6366F1"/>
+          </a:solidFill>
+        </p:spPr>
+        <p:style>
+          <a:lnRef idx="1">
+            <a:schemeClr val="accent1"/>
+          </a:lnRef>
+          <a:fillRef idx="3">
+            <a:schemeClr val="accent1"/>
+          </a:fillRef>
+          <a:effectRef idx="2">
+            <a:schemeClr val="accent1"/>
+          </a:effectRef>
+          <a:fontRef idx="minor">
+            <a:schemeClr val="lt1"/>
+          </a:fontRef>
+        </p:style>
+        <p:txBody>
+          <a:bodyPr rtlCol="0" anchor="ctr"/>
+          <a:lstStyle/>
+          <a:p>
+            <a:pPr algn="ctr"/>
+          </a:p>
+        </p:txBody>
+      </p:sp>
+      <p:sp>
+        <p:nvSpPr>
+          <p:cNvPr id="5" name="Rounded Rectangle 4"/>
+          <p:cNvSpPr/>
+          <p:nvPr/>
+        </p:nvSpPr>
+        <p:spPr>
+          <a:xfrm>
+            <a:off x="731520" y="5440680"/>
+            <a:ext cx="5212080" cy="914400"/>
           </a:xfrm>
           <a:prstGeom prst="roundRect">
             <a:avLst/>
           </a:prstGeom>
           <a:solidFill>
-            <a:srgbClr val="E5E7EB"/>
+            <a:srgbClr val="EEF2FF"/>
           </a:solidFill>
         </p:spPr>
         <p:style>
@@ -4226,7 +4770,7 @@
             <a:r>
               <a:rPr>
                 <a:solidFill>
-                  <a:srgbClr val="374151"/>
+                  <a:srgbClr val="4338CA"/>
                 </a:solidFill>
               </a:rPr>
               <a:t>Desktop View — sisipkan screenshot</a:t>
@@ -4236,20 +4780,20 @@
       </p:sp>
       <p:sp>
         <p:nvSpPr>
-          <p:cNvPr id="5" name="Rounded Rectangle 4"/>
+          <p:cNvPr id="6" name="Rounded Rectangle 5"/>
           <p:cNvSpPr/>
           <p:nvPr/>
         </p:nvSpPr>
         <p:spPr>
           <a:xfrm>
-            <a:off x="6309360" y="5394960"/>
-            <a:ext cx="5212080" cy="1005840"/>
+            <a:off x="6263640" y="5440680"/>
+            <a:ext cx="5212080" cy="914400"/>
           </a:xfrm>
           <a:prstGeom prst="roundRect">
             <a:avLst/>
           </a:prstGeom>
           <a:solidFill>
-            <a:srgbClr val="E5E7EB"/>
+            <a:srgbClr val="EEF2FF"/>
           </a:solidFill>
         </p:spPr>
         <p:style>
@@ -4273,11 +4817,51 @@
             <a:r>
               <a:rPr>
                 <a:solidFill>
-                  <a:srgbClr val="374151"/>
+                  <a:srgbClr val="4338CA"/>
                 </a:solidFill>
               </a:rPr>
               <a:t>Mobile View — sisipkan screenshot</a:t>
             </a:r>
+          </a:p>
+        </p:txBody>
+      </p:sp>
+      <p:sp>
+        <p:nvSpPr>
+          <p:cNvPr id="7" name="Rectangle 6"/>
+          <p:cNvSpPr/>
+          <p:nvPr/>
+        </p:nvSpPr>
+        <p:spPr>
+          <a:xfrm>
+            <a:off x="731520" y="6446520"/>
+            <a:ext cx="10698480" cy="9144"/>
+          </a:xfrm>
+          <a:prstGeom prst="rect">
+            <a:avLst/>
+          </a:prstGeom>
+          <a:solidFill>
+            <a:srgbClr val="E2E8F0"/>
+          </a:solidFill>
+        </p:spPr>
+        <p:style>
+          <a:lnRef idx="1">
+            <a:schemeClr val="accent1"/>
+          </a:lnRef>
+          <a:fillRef idx="3">
+            <a:schemeClr val="accent1"/>
+          </a:fillRef>
+          <a:effectRef idx="2">
+            <a:schemeClr val="accent1"/>
+          </a:effectRef>
+          <a:fontRef idx="minor">
+            <a:schemeClr val="lt1"/>
+          </a:fontRef>
+        </p:style>
+        <p:txBody>
+          <a:bodyPr rtlCol="0" anchor="ctr"/>
+          <a:lstStyle/>
+          <a:p>
+            <a:pPr algn="ctr"/>
           </a:p>
         </p:txBody>
       </p:sp>
@@ -4292,6 +4876,14 @@
 <file path=ppt/slides/slide6.xml><?xml version="1.0" encoding="utf-8"?>
 <p:sld xmlns:a="http://schemas.openxmlformats.org/drawingml/2006/main" xmlns:p="http://schemas.openxmlformats.org/presentationml/2006/main" xmlns:r="http://schemas.openxmlformats.org/officeDocument/2006/relationships">
   <p:cSld>
+    <p:bg>
+      <p:bgPr>
+        <a:solidFill>
+          <a:srgbClr val="0F172A"/>
+        </a:solidFill>
+        <a:effectLst/>
+      </p:bgPr>
+    </p:bg>
     <p:spTree>
       <p:nvGrpSpPr>
         <p:cNvPr id="1" name=""/>
@@ -4307,14 +4899,61 @@
         </p:nvSpPr>
         <p:spPr>
           <a:xfrm>
-            <a:off x="640080" y="1371600"/>
+            <a:off x="640080" y="640080"/>
+            <a:ext cx="6675120" cy="822960"/>
+          </a:xfrm>
+          <a:prstGeom prst="rect">
+            <a:avLst/>
+          </a:prstGeom>
+          <a:solidFill>
+            <a:srgbClr val="6366F1"/>
+          </a:solidFill>
+        </p:spPr>
+        <p:style>
+          <a:lnRef idx="1">
+            <a:schemeClr val="accent1"/>
+          </a:lnRef>
+          <a:fillRef idx="3">
+            <a:schemeClr val="accent1"/>
+          </a:fillRef>
+          <a:effectRef idx="2">
+            <a:schemeClr val="accent1"/>
+          </a:effectRef>
+          <a:fontRef idx="minor">
+            <a:schemeClr val="lt1"/>
+          </a:fontRef>
+        </p:style>
+        <p:txBody>
+          <a:bodyPr rtlCol="0" anchor="ctr"/>
+          <a:lstStyle/>
+          <a:p>
+            <a:r>
+              <a:rPr>
+                <a:solidFill>
+                  <a:srgbClr val="FFFFFF"/>
+                </a:solidFill>
+              </a:rPr>
+              <a:t>Potongan Kode — AnimatedAvatar</a:t>
+            </a:r>
+          </a:p>
+        </p:txBody>
+      </p:sp>
+      <p:sp>
+        <p:nvSpPr>
+          <p:cNvPr id="3" name="Rectangle 2"/>
+          <p:cNvSpPr/>
+          <p:nvPr/>
+        </p:nvSpPr>
+        <p:spPr>
+          <a:xfrm>
+            <a:off x="640080" y="1600200"/>
             <a:ext cx="6675120" cy="4480560"/>
           </a:xfrm>
           <a:prstGeom prst="rect">
             <a:avLst/>
           </a:prstGeom>
           <a:solidFill>
-            <a:srgbClr val="0F172A"/>
+            <a:srgbClr val="1E293B"/>
           </a:solidFill>
         </p:spPr>
         <p:style>
@@ -4429,13 +5068,13 @@
       </p:sp>
       <p:sp>
         <p:nvSpPr>
-          <p:cNvPr id="3" name="Rectangle 2"/>
+          <p:cNvPr id="4" name="Rectangle 3"/>
           <p:cNvSpPr/>
           <p:nvPr/>
         </p:nvSpPr>
         <p:spPr>
           <a:xfrm>
-            <a:off x="7589520" y="1371600"/>
+            <a:off x="7589520" y="1600200"/>
             <a:ext cx="4023360" cy="4480560"/>
           </a:xfrm>
           <a:prstGeom prst="rect">
@@ -4529,6 +5168,14 @@
 <file path=ppt/slides/slide7.xml><?xml version="1.0" encoding="utf-8"?>
 <p:sld xmlns:a="http://schemas.openxmlformats.org/drawingml/2006/main" xmlns:p="http://schemas.openxmlformats.org/presentationml/2006/main" xmlns:r="http://schemas.openxmlformats.org/officeDocument/2006/relationships">
   <p:cSld>
+    <p:bg>
+      <p:bgPr>
+        <a:solidFill>
+          <a:srgbClr val="FFFFFF"/>
+        </a:solidFill>
+        <a:effectLst/>
+      </p:bgPr>
+    </p:bg>
     <p:spTree>
       <p:nvGrpSpPr>
         <p:cNvPr id="1" name=""/>
@@ -4574,35 +5221,55 @@
           <a:p>
             <a:pPr/>
             <a:r>
-              <a:rPr/>
+              <a:rPr b="1">
+                <a:solidFill>
+                  <a:srgbClr val="1E293B"/>
+                </a:solidFill>
+              </a:rPr>
               <a:t>Upaya optimasi yang dilakukan:</a:t>
             </a:r>
           </a:p>
           <a:p>
             <a:pPr/>
             <a:r>
-              <a:rPr/>
+              <a:rPr>
+                <a:solidFill>
+                  <a:srgbClr val="334155"/>
+                </a:solidFill>
+              </a:rPr>
               <a:t>Build produksi Vite (minify, tree-shaking, code-splitting).</a:t>
             </a:r>
           </a:p>
           <a:p>
             <a:pPr/>
             <a:r>
-              <a:rPr/>
+              <a:rPr>
+                <a:solidFill>
+                  <a:srgbClr val="334155"/>
+                </a:solidFill>
+              </a:rPr>
               <a:t>CSS dari Tailwind yang otomatis di-purge (ukuran kecil).</a:t>
             </a:r>
           </a:p>
           <a:p>
             <a:pPr/>
             <a:r>
-              <a:rPr/>
+              <a:rPr>
+                <a:solidFill>
+                  <a:srgbClr val="334155"/>
+                </a:solidFill>
+              </a:rPr>
               <a:t>Avatar &amp; background berbasis CSS/SVG — tanpa bitmap besar (CLS rendah).</a:t>
             </a:r>
           </a:p>
           <a:p>
             <a:pPr/>
             <a:r>
-              <a:rPr/>
+              <a:rPr>
+                <a:solidFill>
+                  <a:srgbClr val="334155"/>
+                </a:solidFill>
+              </a:rPr>
               <a:t>SPA fallback + robots.txt agar render dan indexing bersih.</a:t>
             </a:r>
           </a:p>
@@ -4610,20 +5277,60 @@
       </p:sp>
       <p:sp>
         <p:nvSpPr>
-          <p:cNvPr id="4" name="Rounded Rectangle 3"/>
+          <p:cNvPr id="4" name="Rectangle 3"/>
           <p:cNvSpPr/>
           <p:nvPr/>
         </p:nvSpPr>
         <p:spPr>
           <a:xfrm>
-            <a:off x="731520" y="5394960"/>
-            <a:ext cx="5212080" cy="1005840"/>
+            <a:off x="0" y="0"/>
+            <a:ext cx="256032" cy="6858000"/>
+          </a:xfrm>
+          <a:prstGeom prst="rect">
+            <a:avLst/>
+          </a:prstGeom>
+          <a:solidFill>
+            <a:srgbClr val="6366F1"/>
+          </a:solidFill>
+        </p:spPr>
+        <p:style>
+          <a:lnRef idx="1">
+            <a:schemeClr val="accent1"/>
+          </a:lnRef>
+          <a:fillRef idx="3">
+            <a:schemeClr val="accent1"/>
+          </a:fillRef>
+          <a:effectRef idx="2">
+            <a:schemeClr val="accent1"/>
+          </a:effectRef>
+          <a:fontRef idx="minor">
+            <a:schemeClr val="lt1"/>
+          </a:fontRef>
+        </p:style>
+        <p:txBody>
+          <a:bodyPr rtlCol="0" anchor="ctr"/>
+          <a:lstStyle/>
+          <a:p>
+            <a:pPr algn="ctr"/>
+          </a:p>
+        </p:txBody>
+      </p:sp>
+      <p:sp>
+        <p:nvSpPr>
+          <p:cNvPr id="5" name="Rounded Rectangle 4"/>
+          <p:cNvSpPr/>
+          <p:nvPr/>
+        </p:nvSpPr>
+        <p:spPr>
+          <a:xfrm>
+            <a:off x="731520" y="5440680"/>
+            <a:ext cx="5212080" cy="914400"/>
           </a:xfrm>
           <a:prstGeom prst="roundRect">
             <a:avLst/>
           </a:prstGeom>
           <a:solidFill>
-            <a:srgbClr val="E5E7EB"/>
+            <a:srgbClr val="EEF2FF"/>
           </a:solidFill>
         </p:spPr>
         <p:style>
@@ -4647,7 +5354,7 @@
             <a:r>
               <a:rPr>
                 <a:solidFill>
-                  <a:srgbClr val="374151"/>
+                  <a:srgbClr val="4338CA"/>
                 </a:solidFill>
               </a:rPr>
               <a:t>Skor Mobile — sisipkan screenshot</a:t>
@@ -4657,20 +5364,20 @@
       </p:sp>
       <p:sp>
         <p:nvSpPr>
-          <p:cNvPr id="5" name="Rounded Rectangle 4"/>
+          <p:cNvPr id="6" name="Rounded Rectangle 5"/>
           <p:cNvSpPr/>
           <p:nvPr/>
         </p:nvSpPr>
         <p:spPr>
           <a:xfrm>
-            <a:off x="6309360" y="5394960"/>
-            <a:ext cx="5212080" cy="1005840"/>
+            <a:off x="6263640" y="5440680"/>
+            <a:ext cx="5212080" cy="914400"/>
           </a:xfrm>
           <a:prstGeom prst="roundRect">
             <a:avLst/>
           </a:prstGeom>
           <a:solidFill>
-            <a:srgbClr val="E5E7EB"/>
+            <a:srgbClr val="EEF2FF"/>
           </a:solidFill>
         </p:spPr>
         <p:style>
@@ -4694,11 +5401,51 @@
             <a:r>
               <a:rPr>
                 <a:solidFill>
-                  <a:srgbClr val="374151"/>
+                  <a:srgbClr val="4338CA"/>
                 </a:solidFill>
               </a:rPr>
               <a:t>Skor Desktop — sisipkan screenshot</a:t>
             </a:r>
+          </a:p>
+        </p:txBody>
+      </p:sp>
+      <p:sp>
+        <p:nvSpPr>
+          <p:cNvPr id="7" name="Rectangle 6"/>
+          <p:cNvSpPr/>
+          <p:nvPr/>
+        </p:nvSpPr>
+        <p:spPr>
+          <a:xfrm>
+            <a:off x="731520" y="6446520"/>
+            <a:ext cx="10698480" cy="9144"/>
+          </a:xfrm>
+          <a:prstGeom prst="rect">
+            <a:avLst/>
+          </a:prstGeom>
+          <a:solidFill>
+            <a:srgbClr val="E2E8F0"/>
+          </a:solidFill>
+        </p:spPr>
+        <p:style>
+          <a:lnRef idx="1">
+            <a:schemeClr val="accent1"/>
+          </a:lnRef>
+          <a:fillRef idx="3">
+            <a:schemeClr val="accent1"/>
+          </a:fillRef>
+          <a:effectRef idx="2">
+            <a:schemeClr val="accent1"/>
+          </a:effectRef>
+          <a:fontRef idx="minor">
+            <a:schemeClr val="lt1"/>
+          </a:fontRef>
+        </p:style>
+        <p:txBody>
+          <a:bodyPr rtlCol="0" anchor="ctr"/>
+          <a:lstStyle/>
+          <a:p>
+            <a:pPr algn="ctr"/>
           </a:p>
         </p:txBody>
       </p:sp>
@@ -4713,6 +5460,14 @@
 <file path=ppt/slides/slide8.xml><?xml version="1.0" encoding="utf-8"?>
 <p:sld xmlns:a="http://schemas.openxmlformats.org/drawingml/2006/main" xmlns:p="http://schemas.openxmlformats.org/presentationml/2006/main" xmlns:r="http://schemas.openxmlformats.org/officeDocument/2006/relationships">
   <p:cSld>
+    <p:bg>
+      <p:bgPr>
+        <a:solidFill>
+          <a:srgbClr val="FFFFFF"/>
+        </a:solidFill>
+        <a:effectLst/>
+      </p:bgPr>
+    </p:bg>
     <p:spTree>
       <p:nvGrpSpPr>
         <p:cNvPr id="1" name=""/>
@@ -4729,8 +5484,8 @@
           <p:nvPr/>
         </p:nvGraphicFramePr>
         <p:xfrm>
-          <a:off x="914400" y="1463040"/>
-          <a:ext cx="10332720" cy="4206240"/>
+          <a:off x="640080" y="1691640"/>
+          <a:ext cx="10881360" cy="4389120"/>
         </p:xfrm>
         <a:graphic>
           <a:graphicData uri="http://schemas.openxmlformats.org/drawingml/2006/table">
@@ -4739,10 +5494,10 @@
                 <a:tableStyleId>{5C22544A-7EE6-4342-B048-85BDC9FD1C3A}</a:tableStyleId>
               </a:tblPr>
               <a:tblGrid>
-                <a:gridCol w="5166360"/>
-                <a:gridCol w="5166360"/>
+                <a:gridCol w="5440680"/>
+                <a:gridCol w="5440680"/>
               </a:tblGrid>
-              <a:tr h="600891">
+              <a:tr h="627017">
                 <a:tc>
                   <a:txBody>
                     <a:bodyPr/>
@@ -4768,7 +5523,7 @@
                   <a:tcPr/>
                 </a:tc>
               </a:tr>
-              <a:tr h="600891">
+              <a:tr h="627017">
                 <a:tc>
                   <a:txBody>
                     <a:bodyPr/>
@@ -4794,7 +5549,7 @@
                   <a:tcPr/>
                 </a:tc>
               </a:tr>
-              <a:tr h="600891">
+              <a:tr h="627017">
                 <a:tc>
                   <a:txBody>
                     <a:bodyPr/>
@@ -4820,7 +5575,7 @@
                   <a:tcPr/>
                 </a:tc>
               </a:tr>
-              <a:tr h="600891">
+              <a:tr h="627017">
                 <a:tc>
                   <a:txBody>
                     <a:bodyPr/>
@@ -4846,7 +5601,7 @@
                   <a:tcPr/>
                 </a:tc>
               </a:tr>
-              <a:tr h="600891">
+              <a:tr h="627017">
                 <a:tc>
                   <a:txBody>
                     <a:bodyPr/>
@@ -4872,7 +5627,7 @@
                   <a:tcPr/>
                 </a:tc>
               </a:tr>
-              <a:tr h="600891">
+              <a:tr h="627017">
                 <a:tc>
                   <a:txBody>
                     <a:bodyPr/>
@@ -4898,7 +5653,7 @@
                   <a:tcPr/>
                 </a:tc>
               </a:tr>
-              <a:tr h="600894">
+              <a:tr h="627018">
                 <a:tc>
                   <a:txBody>
                     <a:bodyPr/>
@@ -4928,6 +5683,93 @@
           </a:graphicData>
         </a:graphic>
       </p:graphicFrame>
+      <p:sp>
+        <p:nvSpPr>
+          <p:cNvPr id="3" name="Rectangle 2"/>
+          <p:cNvSpPr/>
+          <p:nvPr/>
+        </p:nvSpPr>
+        <p:spPr>
+          <a:xfrm>
+            <a:off x="0" y="0"/>
+            <a:ext cx="256032" cy="6858000"/>
+          </a:xfrm>
+          <a:prstGeom prst="rect">
+            <a:avLst/>
+          </a:prstGeom>
+          <a:solidFill>
+            <a:srgbClr val="6366F1"/>
+          </a:solidFill>
+        </p:spPr>
+        <p:style>
+          <a:lnRef idx="1">
+            <a:schemeClr val="accent1"/>
+          </a:lnRef>
+          <a:fillRef idx="3">
+            <a:schemeClr val="accent1"/>
+          </a:fillRef>
+          <a:effectRef idx="2">
+            <a:schemeClr val="accent1"/>
+          </a:effectRef>
+          <a:fontRef idx="minor">
+            <a:schemeClr val="lt1"/>
+          </a:fontRef>
+        </p:style>
+        <p:txBody>
+          <a:bodyPr rtlCol="0" anchor="ctr"/>
+          <a:lstStyle/>
+          <a:p>
+            <a:pPr algn="ctr"/>
+          </a:p>
+        </p:txBody>
+      </p:sp>
+      <p:sp>
+        <p:nvSpPr>
+          <p:cNvPr id="4" name="Rectangle 3"/>
+          <p:cNvSpPr/>
+          <p:nvPr/>
+        </p:nvSpPr>
+        <p:spPr>
+          <a:xfrm>
+            <a:off x="640080" y="640080"/>
+            <a:ext cx="10881360" cy="822960"/>
+          </a:xfrm>
+          <a:prstGeom prst="rect">
+            <a:avLst/>
+          </a:prstGeom>
+          <a:solidFill>
+            <a:srgbClr val="6366F1"/>
+          </a:solidFill>
+        </p:spPr>
+        <p:style>
+          <a:lnRef idx="1">
+            <a:schemeClr val="accent1"/>
+          </a:lnRef>
+          <a:fillRef idx="3">
+            <a:schemeClr val="accent1"/>
+          </a:fillRef>
+          <a:effectRef idx="2">
+            <a:schemeClr val="accent1"/>
+          </a:effectRef>
+          <a:fontRef idx="minor">
+            <a:schemeClr val="lt1"/>
+          </a:fontRef>
+        </p:style>
+        <p:txBody>
+          <a:bodyPr rtlCol="0" anchor="ctr"/>
+          <a:lstStyle/>
+          <a:p>
+            <a:r>
+              <a:rPr>
+                <a:solidFill>
+                  <a:srgbClr val="FFFFFF"/>
+                </a:solidFill>
+              </a:rPr>
+              <a:t>Development Module List</a:t>
+            </a:r>
+          </a:p>
+        </p:txBody>
+      </p:sp>
     </p:spTree>
   </p:cSld>
   <p:clrMapOvr>
@@ -4939,6 +5781,14 @@
 <file path=ppt/slides/slide9.xml><?xml version="1.0" encoding="utf-8"?>
 <p:sld xmlns:a="http://schemas.openxmlformats.org/drawingml/2006/main" xmlns:p="http://schemas.openxmlformats.org/presentationml/2006/main" xmlns:r="http://schemas.openxmlformats.org/officeDocument/2006/relationships">
   <p:cSld>
+    <p:bg>
+      <p:bgPr>
+        <a:solidFill>
+          <a:srgbClr val="0F172A"/>
+        </a:solidFill>
+        <a:effectLst/>
+      </p:bgPr>
+    </p:bg>
     <p:spTree>
       <p:nvGrpSpPr>
         <p:cNvPr id="1" name=""/>
@@ -4953,7 +5803,7 @@
             <a:spLocks noGrp="1"/>
           </p:cNvSpPr>
           <p:nvPr>
-            <p:ph type="title"/>
+            <p:ph type="ctrTitle"/>
           </p:nvPr>
         </p:nvSpPr>
         <p:spPr/>
@@ -4969,12 +5819,12 @@
       </p:sp>
       <p:sp>
         <p:nvSpPr>
-          <p:cNvPr id="3" name="Content Placeholder 2"/>
-          <p:cNvSpPr>
-            <a:spLocks noGrp="1"/>
-          </p:cNvSpPr>
-          <p:nvPr>
-            <p:ph idx="1"/>
+          <p:cNvPr id="3" name="Subtitle 2"/>
+          <p:cNvSpPr>
+            <a:spLocks noGrp="1"/>
+          </p:cNvSpPr>
+          <p:nvPr>
+            <p:ph type="subTitle" idx="1"/>
           </p:nvPr>
         </p:nvSpPr>
         <p:spPr/>
@@ -4982,39 +5832,184 @@
           <a:bodyPr/>
           <a:lstStyle/>
           <a:p>
-            <a:pPr/>
-            <a:r>
-              <a:rPr/>
-              <a:t>Email: davidmuhamad97@gmail.com</a:t>
-            </a:r>
-          </a:p>
-          <a:p>
-            <a:pPr/>
-            <a:r>
-              <a:rPr/>
-              <a:t>GitHub: github.com/davidmuhamad97-ops</a:t>
-            </a:r>
-          </a:p>
-          <a:p>
-            <a:pPr/>
-            <a:r>
-              <a:rPr/>
-              <a:t>LinkedIn: linkedin.com/in/muhamad-david-8674b2155</a:t>
-            </a:r>
-          </a:p>
-          <a:p>
-            <a:pPr/>
-            <a:r>
-              <a:rPr/>
-              <a:t>Live Demo: my-personalweb-swart.vercel.app</a:t>
-            </a:r>
-          </a:p>
-          <a:p>
-            <a:pPr/>
-            <a:r>
-              <a:rPr b="1"/>
-              <a:t>Terima kasih atas perhatiannya.</a:t>
-            </a:r>
+            <a:r>
+              <a:t>davidmuhamad97@gmail.com</a:t>
+            </a:r>
+          </a:p>
+          <a:p>
+            <a:r>
+              <a:t>github.com/davidmuhamad97-ops</a:t>
+            </a:r>
+          </a:p>
+          <a:p>
+            <a:r>
+              <a:t>linkedin.com/in/muhamad-david-8674b2155</a:t>
+            </a:r>
+          </a:p>
+          <a:p>
+            <a:r>
+              <a:t>my-personalweb-swart.vercel.app</a:t>
+            </a:r>
+          </a:p>
+        </p:txBody>
+      </p:sp>
+      <p:sp>
+        <p:nvSpPr>
+          <p:cNvPr id="4" name="Rectangle 3"/>
+          <p:cNvSpPr/>
+          <p:nvPr/>
+        </p:nvSpPr>
+        <p:spPr>
+          <a:xfrm>
+            <a:off x="0" y="0"/>
+            <a:ext cx="256032" cy="6858000"/>
+          </a:xfrm>
+          <a:prstGeom prst="rect">
+            <a:avLst/>
+          </a:prstGeom>
+          <a:solidFill>
+            <a:srgbClr val="6366F1"/>
+          </a:solidFill>
+        </p:spPr>
+        <p:style>
+          <a:lnRef idx="1">
+            <a:schemeClr val="accent1"/>
+          </a:lnRef>
+          <a:fillRef idx="3">
+            <a:schemeClr val="accent1"/>
+          </a:fillRef>
+          <a:effectRef idx="2">
+            <a:schemeClr val="accent1"/>
+          </a:effectRef>
+          <a:fontRef idx="minor">
+            <a:schemeClr val="lt1"/>
+          </a:fontRef>
+        </p:style>
+        <p:txBody>
+          <a:bodyPr rtlCol="0" anchor="ctr"/>
+          <a:lstStyle/>
+          <a:p>
+            <a:pPr algn="ctr"/>
+          </a:p>
+        </p:txBody>
+      </p:sp>
+      <p:sp>
+        <p:nvSpPr>
+          <p:cNvPr id="5" name="Rectangle 4"/>
+          <p:cNvSpPr/>
+          <p:nvPr/>
+        </p:nvSpPr>
+        <p:spPr>
+          <a:xfrm>
+            <a:off x="777240" y="3291840"/>
+            <a:ext cx="2194560" cy="73152"/>
+          </a:xfrm>
+          <a:prstGeom prst="rect">
+            <a:avLst/>
+          </a:prstGeom>
+          <a:solidFill>
+            <a:srgbClr val="8B5CF6"/>
+          </a:solidFill>
+        </p:spPr>
+        <p:style>
+          <a:lnRef idx="1">
+            <a:schemeClr val="accent1"/>
+          </a:lnRef>
+          <a:fillRef idx="3">
+            <a:schemeClr val="accent1"/>
+          </a:fillRef>
+          <a:effectRef idx="2">
+            <a:schemeClr val="accent1"/>
+          </a:effectRef>
+          <a:fontRef idx="minor">
+            <a:schemeClr val="lt1"/>
+          </a:fontRef>
+        </p:style>
+        <p:txBody>
+          <a:bodyPr rtlCol="0" anchor="ctr"/>
+          <a:lstStyle/>
+          <a:p>
+            <a:pPr algn="ctr"/>
+          </a:p>
+        </p:txBody>
+      </p:sp>
+      <p:sp>
+        <p:nvSpPr>
+          <p:cNvPr id="6" name="Oval 5"/>
+          <p:cNvSpPr/>
+          <p:nvPr/>
+        </p:nvSpPr>
+        <p:spPr>
+          <a:xfrm>
+            <a:off x="10241280" y="-1097280"/>
+            <a:ext cx="2926080" cy="2926080"/>
+          </a:xfrm>
+          <a:prstGeom prst="ellipse">
+            <a:avLst/>
+          </a:prstGeom>
+          <a:solidFill>
+            <a:srgbClr val="4F46E5"/>
+          </a:solidFill>
+        </p:spPr>
+        <p:style>
+          <a:lnRef idx="1">
+            <a:schemeClr val="accent1"/>
+          </a:lnRef>
+          <a:fillRef idx="3">
+            <a:schemeClr val="accent1"/>
+          </a:fillRef>
+          <a:effectRef idx="2">
+            <a:schemeClr val="accent1"/>
+          </a:effectRef>
+          <a:fontRef idx="minor">
+            <a:schemeClr val="lt1"/>
+          </a:fontRef>
+        </p:style>
+        <p:txBody>
+          <a:bodyPr rtlCol="0" anchor="ctr"/>
+          <a:lstStyle/>
+          <a:p>
+            <a:pPr algn="ctr"/>
+          </a:p>
+        </p:txBody>
+      </p:sp>
+      <p:sp>
+        <p:nvSpPr>
+          <p:cNvPr id="7" name="Oval 6"/>
+          <p:cNvSpPr/>
+          <p:nvPr/>
+        </p:nvSpPr>
+        <p:spPr>
+          <a:xfrm>
+            <a:off x="9692640" y="4754880"/>
+            <a:ext cx="2377440" cy="2377440"/>
+          </a:xfrm>
+          <a:prstGeom prst="ellipse">
+            <a:avLst/>
+          </a:prstGeom>
+          <a:solidFill>
+            <a:srgbClr val="7C3AED"/>
+          </a:solidFill>
+        </p:spPr>
+        <p:style>
+          <a:lnRef idx="1">
+            <a:schemeClr val="accent1"/>
+          </a:lnRef>
+          <a:fillRef idx="3">
+            <a:schemeClr val="accent1"/>
+          </a:fillRef>
+          <a:effectRef idx="2">
+            <a:schemeClr val="accent1"/>
+          </a:effectRef>
+          <a:fontRef idx="minor">
+            <a:schemeClr val="lt1"/>
+          </a:fontRef>
+        </p:style>
+        <p:txBody>
+          <a:bodyPr rtlCol="0" anchor="ctr"/>
+          <a:lstStyle/>
+          <a:p>
+            <a:pPr algn="ctr"/>
           </a:p>
         </p:txBody>
       </p:sp>

</xml_diff>

<commit_message>
docs: fix deck fonts/sizes and enlarge PageSpeed screenshot placeholders
</commit_message>
<xml_diff>
--- a/presentation/Code-Challenge-2-Presentasi.pptx
+++ b/presentation/Code-Challenge-2-Presentasi.pptx
@@ -3540,6 +3540,12 @@
           <a:lstStyle/>
           <a:p>
             <a:r>
+              <a:rPr sz="4000" b="1">
+                <a:solidFill>
+                  <a:srgbClr val="FFFFFF"/>
+                </a:solidFill>
+                <a:latin typeface="Calibri"/>
+              </a:rPr>
               <a:t>Personal Website Portfolio</a:t>
             </a:r>
           </a:p>
@@ -3561,21 +3567,45 @@
           <a:lstStyle/>
           <a:p>
             <a:r>
+              <a:rPr sz="1800">
+                <a:solidFill>
+                  <a:srgbClr val="CBD5E1"/>
+                </a:solidFill>
+                <a:latin typeface="Calibri"/>
+              </a:rPr>
               <a:t>Code Challenge 2 — Opsi A</a:t>
             </a:r>
           </a:p>
           <a:p>
             <a:r>
+              <a:rPr sz="1800">
+                <a:solidFill>
+                  <a:srgbClr val="CBD5E1"/>
+                </a:solidFill>
+                <a:latin typeface="Calibri"/>
+              </a:rPr>
               <a:t>JCFSVL</a:t>
             </a:r>
           </a:p>
           <a:p>
             <a:r>
+              <a:rPr sz="1800">
+                <a:solidFill>
+                  <a:srgbClr val="CBD5E1"/>
+                </a:solidFill>
+                <a:latin typeface="Calibri"/>
+              </a:rPr>
               <a:t>Muhammad David</a:t>
             </a:r>
           </a:p>
           <a:p>
             <a:r>
+              <a:rPr sz="1800">
+                <a:solidFill>
+                  <a:srgbClr val="CBD5E1"/>
+                </a:solidFill>
+                <a:latin typeface="Calibri"/>
+              </a:rPr>
               <a:t>2026</a:t>
             </a:r>
           </a:p>
@@ -3783,6 +3813,12 @@
           <a:lstStyle/>
           <a:p>
             <a:r>
+              <a:rPr sz="2800" b="1">
+                <a:solidFill>
+                  <a:srgbClr val="1E293B"/>
+                </a:solidFill>
+                <a:latin typeface="Calibri"/>
+              </a:rPr>
               <a:t>Fitur 1 — Hero &amp; Animated Avatar</a:t>
             </a:r>
           </a:p>
@@ -3805,10 +3841,11 @@
           <a:p>
             <a:pPr/>
             <a:r>
-              <a:rPr>
+              <a:rPr sz="1600">
                 <a:solidFill>
                   <a:srgbClr val="334155"/>
                 </a:solidFill>
+                <a:latin typeface="Calibri"/>
               </a:rPr>
               <a:t>Avatar inisial (MD) berbingkai conic-gradient yang berputar otomatis (spin 4 detik).</a:t>
             </a:r>
@@ -3816,10 +3853,11 @@
           <a:p>
             <a:pPr/>
             <a:r>
-              <a:rPr>
+              <a:rPr sz="1600">
                 <a:solidFill>
                   <a:srgbClr val="334155"/>
                 </a:solidFill>
+                <a:latin typeface="Calibri"/>
               </a:rPr>
               <a:t>Glow pulsing lembut di belakang avatar (efek bernapas, 3 detik).</a:t>
             </a:r>
@@ -3827,10 +3865,11 @@
           <a:p>
             <a:pPr/>
             <a:r>
-              <a:rPr>
+              <a:rPr sz="1600">
                 <a:solidFill>
                   <a:srgbClr val="334155"/>
                 </a:solidFill>
+                <a:latin typeface="Calibri"/>
               </a:rPr>
               <a:t>Background SVG: pola dots + gradient mesh blob di 4 sudut.</a:t>
             </a:r>
@@ -3838,10 +3877,11 @@
           <a:p>
             <a:pPr/>
             <a:r>
-              <a:rPr>
+              <a:rPr sz="1600">
                 <a:solidFill>
                   <a:srgbClr val="334155"/>
                 </a:solidFill>
+                <a:latin typeface="Calibri"/>
               </a:rPr>
               <a:t>Menampilkan nama, job title, lokasi, dan bio singkat dari data profil.</a:t>
             </a:r>
@@ -3896,8 +3936,8 @@
         </p:nvSpPr>
         <p:spPr>
           <a:xfrm>
-            <a:off x="731520" y="5440680"/>
-            <a:ext cx="5212080" cy="914400"/>
+            <a:off x="731520" y="5212080"/>
+            <a:ext cx="5212080" cy="1143000"/>
           </a:xfrm>
           <a:prstGeom prst="roundRect">
             <a:avLst/>
@@ -3925,10 +3965,11 @@
           <a:lstStyle/>
           <a:p>
             <a:r>
-              <a:rPr>
+              <a:rPr sz="1400" b="1">
                 <a:solidFill>
                   <a:srgbClr val="4338CA"/>
                 </a:solidFill>
+                <a:latin typeface="Calibri"/>
               </a:rPr>
               <a:t>Desktop View — sisipkan screenshot</a:t>
             </a:r>
@@ -3943,8 +3984,8 @@
         </p:nvSpPr>
         <p:spPr>
           <a:xfrm>
-            <a:off x="6263640" y="5440680"/>
-            <a:ext cx="5212080" cy="914400"/>
+            <a:off x="6263640" y="5212080"/>
+            <a:ext cx="5212080" cy="1143000"/>
           </a:xfrm>
           <a:prstGeom prst="roundRect">
             <a:avLst/>
@@ -3972,53 +4013,14 @@
           <a:lstStyle/>
           <a:p>
             <a:r>
-              <a:rPr>
+              <a:rPr sz="1400" b="1">
                 <a:solidFill>
                   <a:srgbClr val="4338CA"/>
                 </a:solidFill>
+                <a:latin typeface="Calibri"/>
               </a:rPr>
               <a:t>Mobile View — sisipkan screenshot</a:t>
             </a:r>
-          </a:p>
-        </p:txBody>
-      </p:sp>
-      <p:sp>
-        <p:nvSpPr>
-          <p:cNvPr id="7" name="Rectangle 6"/>
-          <p:cNvSpPr/>
-          <p:nvPr/>
-        </p:nvSpPr>
-        <p:spPr>
-          <a:xfrm>
-            <a:off x="731520" y="6446520"/>
-            <a:ext cx="10698480" cy="9144"/>
-          </a:xfrm>
-          <a:prstGeom prst="rect">
-            <a:avLst/>
-          </a:prstGeom>
-          <a:solidFill>
-            <a:srgbClr val="E2E8F0"/>
-          </a:solidFill>
-        </p:spPr>
-        <p:style>
-          <a:lnRef idx="1">
-            <a:schemeClr val="accent1"/>
-          </a:lnRef>
-          <a:fillRef idx="3">
-            <a:schemeClr val="accent1"/>
-          </a:fillRef>
-          <a:effectRef idx="2">
-            <a:schemeClr val="accent1"/>
-          </a:effectRef>
-          <a:fontRef idx="minor">
-            <a:schemeClr val="lt1"/>
-          </a:fontRef>
-        </p:style>
-        <p:txBody>
-          <a:bodyPr rtlCol="0" anchor="ctr"/>
-          <a:lstStyle/>
-          <a:p>
-            <a:pPr algn="ctr"/>
           </a:p>
         </p:txBody>
       </p:sp>
@@ -4064,6 +4066,12 @@
           <a:lstStyle/>
           <a:p>
             <a:r>
+              <a:rPr sz="2800" b="1">
+                <a:solidFill>
+                  <a:srgbClr val="1E293B"/>
+                </a:solidFill>
+                <a:latin typeface="Calibri"/>
+              </a:rPr>
               <a:t>Fitur 2 — Sticky Navbar &amp; ScrollSpy</a:t>
             </a:r>
           </a:p>
@@ -4086,10 +4094,11 @@
           <a:p>
             <a:pPr/>
             <a:r>
-              <a:rPr>
+              <a:rPr sz="1600">
                 <a:solidFill>
                   <a:srgbClr val="334155"/>
                 </a:solidFill>
+                <a:latin typeface="Calibri"/>
               </a:rPr>
               <a:t>Navbar sticky dengan backdrop-blur agar tetap terlihat saat scroll.</a:t>
             </a:r>
@@ -4097,10 +4106,11 @@
           <a:p>
             <a:pPr/>
             <a:r>
-              <a:rPr>
+              <a:rPr sz="1600">
                 <a:solidFill>
                   <a:srgbClr val="334155"/>
                 </a:solidFill>
+                <a:latin typeface="Calibri"/>
               </a:rPr>
               <a:t>Underline beranimasi muncul saat hover dan menetap pada menu aktif.</a:t>
             </a:r>
@@ -4108,10 +4118,11 @@
           <a:p>
             <a:pPr/>
             <a:r>
-              <a:rPr>
+              <a:rPr sz="1600">
                 <a:solidFill>
                   <a:srgbClr val="334155"/>
                 </a:solidFill>
+                <a:latin typeface="Calibri"/>
               </a:rPr>
               <a:t>Hook useScrollSpy memakai IntersectionObserver untuk mendeteksi section yang sedang dilihat.</a:t>
             </a:r>
@@ -4119,10 +4130,11 @@
           <a:p>
             <a:pPr/>
             <a:r>
-              <a:rPr>
+              <a:rPr sz="1600">
                 <a:solidFill>
                   <a:srgbClr val="334155"/>
                 </a:solidFill>
+                <a:latin typeface="Calibri"/>
               </a:rPr>
               <a:t>Smooth scrolling antar section (CSS scroll-behavior: smooth + scroll-margin-top).</a:t>
             </a:r>
@@ -4177,8 +4189,8 @@
         </p:nvSpPr>
         <p:spPr>
           <a:xfrm>
-            <a:off x="731520" y="5440680"/>
-            <a:ext cx="5212080" cy="914400"/>
+            <a:off x="731520" y="5212080"/>
+            <a:ext cx="5212080" cy="1143000"/>
           </a:xfrm>
           <a:prstGeom prst="roundRect">
             <a:avLst/>
@@ -4206,10 +4218,11 @@
           <a:lstStyle/>
           <a:p>
             <a:r>
-              <a:rPr>
+              <a:rPr sz="1400" b="1">
                 <a:solidFill>
                   <a:srgbClr val="4338CA"/>
                 </a:solidFill>
+                <a:latin typeface="Calibri"/>
               </a:rPr>
               <a:t>Desktop View — sisipkan screenshot</a:t>
             </a:r>
@@ -4224,8 +4237,8 @@
         </p:nvSpPr>
         <p:spPr>
           <a:xfrm>
-            <a:off x="6263640" y="5440680"/>
-            <a:ext cx="5212080" cy="914400"/>
+            <a:off x="6263640" y="5212080"/>
+            <a:ext cx="5212080" cy="1143000"/>
           </a:xfrm>
           <a:prstGeom prst="roundRect">
             <a:avLst/>
@@ -4253,53 +4266,14 @@
           <a:lstStyle/>
           <a:p>
             <a:r>
-              <a:rPr>
+              <a:rPr sz="1400" b="1">
                 <a:solidFill>
                   <a:srgbClr val="4338CA"/>
                 </a:solidFill>
+                <a:latin typeface="Calibri"/>
               </a:rPr>
               <a:t>Mobile View — sisipkan screenshot</a:t>
             </a:r>
-          </a:p>
-        </p:txBody>
-      </p:sp>
-      <p:sp>
-        <p:nvSpPr>
-          <p:cNvPr id="7" name="Rectangle 6"/>
-          <p:cNvSpPr/>
-          <p:nvPr/>
-        </p:nvSpPr>
-        <p:spPr>
-          <a:xfrm>
-            <a:off x="731520" y="6446520"/>
-            <a:ext cx="10698480" cy="9144"/>
-          </a:xfrm>
-          <a:prstGeom prst="rect">
-            <a:avLst/>
-          </a:prstGeom>
-          <a:solidFill>
-            <a:srgbClr val="E2E8F0"/>
-          </a:solidFill>
-        </p:spPr>
-        <p:style>
-          <a:lnRef idx="1">
-            <a:schemeClr val="accent1"/>
-          </a:lnRef>
-          <a:fillRef idx="3">
-            <a:schemeClr val="accent1"/>
-          </a:fillRef>
-          <a:effectRef idx="2">
-            <a:schemeClr val="accent1"/>
-          </a:effectRef>
-          <a:fontRef idx="minor">
-            <a:schemeClr val="lt1"/>
-          </a:fontRef>
-        </p:style>
-        <p:txBody>
-          <a:bodyPr rtlCol="0" anchor="ctr"/>
-          <a:lstStyle/>
-          <a:p>
-            <a:pPr algn="ctr"/>
           </a:p>
         </p:txBody>
       </p:sp>
@@ -4345,6 +4319,12 @@
           <a:lstStyle/>
           <a:p>
             <a:r>
+              <a:rPr sz="2800" b="1">
+                <a:solidFill>
+                  <a:srgbClr val="1E293B"/>
+                </a:solidFill>
+                <a:latin typeface="Calibri"/>
+              </a:rPr>
               <a:t>Fitur 3 — Gradient Cards &amp; Hover Animation</a:t>
             </a:r>
           </a:p>
@@ -4367,10 +4347,11 @@
           <a:p>
             <a:pPr/>
             <a:r>
-              <a:rPr>
+              <a:rPr sz="1600">
                 <a:solidFill>
                   <a:srgbClr val="334155"/>
                 </a:solidFill>
+                <a:latin typeface="Calibri"/>
               </a:rPr>
               <a:t>Skills, Experience, dan Testimonials memakai kartu gradient berwarna (indigo, sky, teal, fuchsia).</a:t>
             </a:r>
@@ -4378,10 +4359,11 @@
           <a:p>
             <a:pPr/>
             <a:r>
-              <a:rPr>
+              <a:rPr sz="1600">
                 <a:solidFill>
                   <a:srgbClr val="334155"/>
                 </a:solidFill>
+                <a:latin typeface="Calibri"/>
               </a:rPr>
               <a:t>Hover: kartu terangkat (translate-y) + shadow membesar.</a:t>
             </a:r>
@@ -4389,10 +4371,11 @@
           <a:p>
             <a:pPr/>
             <a:r>
-              <a:rPr>
+              <a:rPr sz="1600">
                 <a:solidFill>
                   <a:srgbClr val="334155"/>
                 </a:solidFill>
+                <a:latin typeface="Calibri"/>
               </a:rPr>
               <a:t>Background kartu berubah warna saat hover (section Skills).</a:t>
             </a:r>
@@ -4400,10 +4383,11 @@
           <a:p>
             <a:pPr/>
             <a:r>
-              <a:rPr>
+              <a:rPr sz="1600">
                 <a:solidFill>
                   <a:srgbClr val="334155"/>
                 </a:solidFill>
+                <a:latin typeface="Calibri"/>
               </a:rPr>
               <a:t>Light bloom + elemen dekoratif muncul saat hover di setiap kartu.</a:t>
             </a:r>
@@ -4458,8 +4442,8 @@
         </p:nvSpPr>
         <p:spPr>
           <a:xfrm>
-            <a:off x="731520" y="5440680"/>
-            <a:ext cx="5212080" cy="914400"/>
+            <a:off x="731520" y="5212080"/>
+            <a:ext cx="5212080" cy="1143000"/>
           </a:xfrm>
           <a:prstGeom prst="roundRect">
             <a:avLst/>
@@ -4487,10 +4471,11 @@
           <a:lstStyle/>
           <a:p>
             <a:r>
-              <a:rPr>
+              <a:rPr sz="1400" b="1">
                 <a:solidFill>
                   <a:srgbClr val="4338CA"/>
                 </a:solidFill>
+                <a:latin typeface="Calibri"/>
               </a:rPr>
               <a:t>Desktop View — sisipkan screenshot</a:t>
             </a:r>
@@ -4505,8 +4490,8 @@
         </p:nvSpPr>
         <p:spPr>
           <a:xfrm>
-            <a:off x="6263640" y="5440680"/>
-            <a:ext cx="5212080" cy="914400"/>
+            <a:off x="6263640" y="5212080"/>
+            <a:ext cx="5212080" cy="1143000"/>
           </a:xfrm>
           <a:prstGeom prst="roundRect">
             <a:avLst/>
@@ -4534,53 +4519,14 @@
           <a:lstStyle/>
           <a:p>
             <a:r>
-              <a:rPr>
+              <a:rPr sz="1400" b="1">
                 <a:solidFill>
                   <a:srgbClr val="4338CA"/>
                 </a:solidFill>
+                <a:latin typeface="Calibri"/>
               </a:rPr>
               <a:t>Mobile View — sisipkan screenshot</a:t>
             </a:r>
-          </a:p>
-        </p:txBody>
-      </p:sp>
-      <p:sp>
-        <p:nvSpPr>
-          <p:cNvPr id="7" name="Rectangle 6"/>
-          <p:cNvSpPr/>
-          <p:nvPr/>
-        </p:nvSpPr>
-        <p:spPr>
-          <a:xfrm>
-            <a:off x="731520" y="6446520"/>
-            <a:ext cx="10698480" cy="9144"/>
-          </a:xfrm>
-          <a:prstGeom prst="rect">
-            <a:avLst/>
-          </a:prstGeom>
-          <a:solidFill>
-            <a:srgbClr val="E2E8F0"/>
-          </a:solidFill>
-        </p:spPr>
-        <p:style>
-          <a:lnRef idx="1">
-            <a:schemeClr val="accent1"/>
-          </a:lnRef>
-          <a:fillRef idx="3">
-            <a:schemeClr val="accent1"/>
-          </a:fillRef>
-          <a:effectRef idx="2">
-            <a:schemeClr val="accent1"/>
-          </a:effectRef>
-          <a:fontRef idx="minor">
-            <a:schemeClr val="lt1"/>
-          </a:fontRef>
-        </p:style>
-        <p:txBody>
-          <a:bodyPr rtlCol="0" anchor="ctr"/>
-          <a:lstStyle/>
-          <a:p>
-            <a:pPr algn="ctr"/>
           </a:p>
         </p:txBody>
       </p:sp>
@@ -4626,6 +4572,12 @@
           <a:lstStyle/>
           <a:p>
             <a:r>
+              <a:rPr sz="2800" b="1">
+                <a:solidFill>
+                  <a:srgbClr val="1E293B"/>
+                </a:solidFill>
+                <a:latin typeface="Calibri"/>
+              </a:rPr>
               <a:t>Fitur 4 — Responsive &amp; Performa</a:t>
             </a:r>
           </a:p>
@@ -4648,10 +4600,11 @@
           <a:p>
             <a:pPr/>
             <a:r>
-              <a:rPr>
+              <a:rPr sz="1600">
                 <a:solidFill>
                   <a:srgbClr val="334155"/>
                 </a:solidFill>
+                <a:latin typeface="Calibri"/>
               </a:rPr>
               <a:t>Single-page application (React Router) dengan SPA fallback di Vercel.</a:t>
             </a:r>
@@ -4659,10 +4612,11 @@
           <a:p>
             <a:pPr/>
             <a:r>
-              <a:rPr>
+              <a:rPr sz="1600">
                 <a:solidFill>
                   <a:srgbClr val="334155"/>
                 </a:solidFill>
+                <a:latin typeface="Calibri"/>
               </a:rPr>
               <a:t>Mobile-first memakai Tailwind responsive breakpoints.</a:t>
             </a:r>
@@ -4670,10 +4624,11 @@
           <a:p>
             <a:pPr/>
             <a:r>
-              <a:rPr>
+              <a:rPr sz="1600">
                 <a:solidFill>
                   <a:srgbClr val="334155"/>
                 </a:solidFill>
+                <a:latin typeface="Calibri"/>
               </a:rPr>
               <a:t>Aset gambar minim: avatar &amp; background berbasis CSS/SVG, tanpa bitmap besar.</a:t>
             </a:r>
@@ -4681,10 +4636,11 @@
           <a:p>
             <a:pPr/>
             <a:r>
-              <a:rPr>
+              <a:rPr sz="1600">
                 <a:solidFill>
                   <a:srgbClr val="334155"/>
                 </a:solidFill>
+                <a:latin typeface="Calibri"/>
               </a:rPr>
               <a:t>Meta tags, robots.txt, dan SEO dasar pada index.html.</a:t>
             </a:r>
@@ -4739,8 +4695,8 @@
         </p:nvSpPr>
         <p:spPr>
           <a:xfrm>
-            <a:off x="731520" y="5440680"/>
-            <a:ext cx="5212080" cy="914400"/>
+            <a:off x="731520" y="5212080"/>
+            <a:ext cx="5212080" cy="1143000"/>
           </a:xfrm>
           <a:prstGeom prst="roundRect">
             <a:avLst/>
@@ -4768,10 +4724,11 @@
           <a:lstStyle/>
           <a:p>
             <a:r>
-              <a:rPr>
+              <a:rPr sz="1400" b="1">
                 <a:solidFill>
                   <a:srgbClr val="4338CA"/>
                 </a:solidFill>
+                <a:latin typeface="Calibri"/>
               </a:rPr>
               <a:t>Desktop View — sisipkan screenshot</a:t>
             </a:r>
@@ -4786,8 +4743,8 @@
         </p:nvSpPr>
         <p:spPr>
           <a:xfrm>
-            <a:off x="6263640" y="5440680"/>
-            <a:ext cx="5212080" cy="914400"/>
+            <a:off x="6263640" y="5212080"/>
+            <a:ext cx="5212080" cy="1143000"/>
           </a:xfrm>
           <a:prstGeom prst="roundRect">
             <a:avLst/>
@@ -4815,53 +4772,14 @@
           <a:lstStyle/>
           <a:p>
             <a:r>
-              <a:rPr>
+              <a:rPr sz="1400" b="1">
                 <a:solidFill>
                   <a:srgbClr val="4338CA"/>
                 </a:solidFill>
+                <a:latin typeface="Calibri"/>
               </a:rPr>
               <a:t>Mobile View — sisipkan screenshot</a:t>
             </a:r>
-          </a:p>
-        </p:txBody>
-      </p:sp>
-      <p:sp>
-        <p:nvSpPr>
-          <p:cNvPr id="7" name="Rectangle 6"/>
-          <p:cNvSpPr/>
-          <p:nvPr/>
-        </p:nvSpPr>
-        <p:spPr>
-          <a:xfrm>
-            <a:off x="731520" y="6446520"/>
-            <a:ext cx="10698480" cy="9144"/>
-          </a:xfrm>
-          <a:prstGeom prst="rect">
-            <a:avLst/>
-          </a:prstGeom>
-          <a:solidFill>
-            <a:srgbClr val="E2E8F0"/>
-          </a:solidFill>
-        </p:spPr>
-        <p:style>
-          <a:lnRef idx="1">
-            <a:schemeClr val="accent1"/>
-          </a:lnRef>
-          <a:fillRef idx="3">
-            <a:schemeClr val="accent1"/>
-          </a:fillRef>
-          <a:effectRef idx="2">
-            <a:schemeClr val="accent1"/>
-          </a:effectRef>
-          <a:fontRef idx="minor">
-            <a:schemeClr val="lt1"/>
-          </a:fontRef>
-        </p:style>
-        <p:txBody>
-          <a:bodyPr rtlCol="0" anchor="ctr"/>
-          <a:lstStyle/>
-          <a:p>
-            <a:pPr algn="ctr"/>
           </a:p>
         </p:txBody>
       </p:sp>
@@ -4928,10 +4846,11 @@
           <a:lstStyle/>
           <a:p>
             <a:r>
-              <a:rPr>
+              <a:rPr sz="2000" b="1">
                 <a:solidFill>
                   <a:srgbClr val="FFFFFF"/>
                 </a:solidFill>
+                <a:latin typeface="Calibri"/>
               </a:rPr>
               <a:t>Potongan Kode — AnimatedAvatar</a:t>
             </a:r>
@@ -4975,92 +4894,141 @@
           <a:lstStyle/>
           <a:p>
             <a:r>
-              <a:rPr>
+              <a:rPr sz="1300">
                 <a:solidFill>
                   <a:srgbClr val="E2E8F0"/>
                 </a:solidFill>
+                <a:latin typeface="Consolas"/>
               </a:rPr>
               <a:t>export function AnimatedAvatar({ name }) {</a:t>
             </a:r>
           </a:p>
           <a:p>
             <a:r>
+              <a:rPr sz="1300">
+                <a:latin typeface="Consolas"/>
+              </a:rPr>
               <a:t>  const initials = name</a:t>
             </a:r>
           </a:p>
           <a:p>
             <a:r>
+              <a:rPr sz="1300">
+                <a:latin typeface="Consolas"/>
+              </a:rPr>
               <a:t>    .split(' ')</a:t>
             </a:r>
           </a:p>
           <a:p>
             <a:r>
+              <a:rPr sz="1300">
+                <a:latin typeface="Consolas"/>
+              </a:rPr>
               <a:t>    .map(p =&gt; p.charAt(0))</a:t>
             </a:r>
           </a:p>
           <a:p>
             <a:r>
+              <a:rPr sz="1300">
+                <a:latin typeface="Consolas"/>
+              </a:rPr>
               <a:t>    .slice(0, 2)</a:t>
             </a:r>
           </a:p>
           <a:p>
             <a:r>
+              <a:rPr sz="1300">
+                <a:latin typeface="Consolas"/>
+              </a:rPr>
               <a:t>    .join('')</a:t>
             </a:r>
           </a:p>
           <a:p>
             <a:r>
+              <a:rPr sz="1300">
+                <a:latin typeface="Consolas"/>
+              </a:rPr>
               <a:t>    .toUpperCase();</a:t>
             </a:r>
           </a:p>
           <a:p/>
           <a:p>
             <a:r>
+              <a:rPr sz="1300">
+                <a:latin typeface="Consolas"/>
+              </a:rPr>
               <a:t>  return (</a:t>
             </a:r>
           </a:p>
           <a:p>
             <a:r>
+              <a:rPr sz="1300">
+                <a:latin typeface="Consolas"/>
+              </a:rPr>
               <a:t>    &lt;div className="relative"&gt;</a:t>
             </a:r>
           </a:p>
           <a:p>
             <a:r>
+              <a:rPr sz="1300">
+                <a:latin typeface="Consolas"/>
+              </a:rPr>
               <a:t>      &lt;div className="conic-gradient animate-spin-slow" /&gt;</a:t>
             </a:r>
           </a:p>
           <a:p>
             <a:r>
+              <a:rPr sz="1300">
+                <a:latin typeface="Consolas"/>
+              </a:rPr>
               <a:t>      &lt;div className="bg-slate-900 rounded-full"&gt;</a:t>
             </a:r>
           </a:p>
           <a:p>
             <a:r>
+              <a:rPr sz="1300">
+                <a:latin typeface="Consolas"/>
+              </a:rPr>
               <a:t>        {initials}</a:t>
             </a:r>
           </a:p>
           <a:p>
             <a:r>
+              <a:rPr sz="1300">
+                <a:latin typeface="Consolas"/>
+              </a:rPr>
               <a:t>      &lt;/div&gt;</a:t>
             </a:r>
           </a:p>
           <a:p>
             <a:r>
+              <a:rPr sz="1300">
+                <a:latin typeface="Consolas"/>
+              </a:rPr>
               <a:t>      &lt;div className="blur-xl animate-pulse-soft" /&gt;</a:t>
             </a:r>
           </a:p>
           <a:p>
             <a:r>
+              <a:rPr sz="1300">
+                <a:latin typeface="Consolas"/>
+              </a:rPr>
               <a:t>    &lt;/div&gt;</a:t>
             </a:r>
           </a:p>
           <a:p>
             <a:r>
+              <a:rPr sz="1300">
+                <a:latin typeface="Consolas"/>
+              </a:rPr>
               <a:t>  );</a:t>
             </a:r>
           </a:p>
           <a:p>
             <a:r>
+              <a:rPr sz="1300">
+                <a:latin typeface="Consolas"/>
+              </a:rPr>
               <a:t>}</a:t>
             </a:r>
           </a:p>
@@ -5103,10 +5071,11 @@
           <a:lstStyle/>
           <a:p>
             <a:r>
-              <a:rPr>
+              <a:rPr sz="1300">
                 <a:solidFill>
                   <a:srgbClr val="1E1B4B"/>
                 </a:solidFill>
+                <a:latin typeface="Calibri"/>
               </a:rPr>
               <a:t>Anotasi:</a:t>
             </a:r>
@@ -5114,44 +5083,68 @@
           <a:p/>
           <a:p>
             <a:r>
+              <a:rPr sz="1300">
+                <a:latin typeface="Calibri"/>
+              </a:rPr>
               <a:t>1. Inisial dihitung dari nama,</a:t>
             </a:r>
           </a:p>
           <a:p>
             <a:r>
+              <a:rPr sz="1300">
+                <a:latin typeface="Calibri"/>
+              </a:rPr>
               <a:t>   lalu dirender di lingkaran tengah.</a:t>
             </a:r>
           </a:p>
           <a:p/>
           <a:p>
             <a:r>
+              <a:rPr sz="1300">
+                <a:latin typeface="Calibri"/>
+              </a:rPr>
               <a:t>2. Ring conic-gradient berputar</a:t>
             </a:r>
           </a:p>
           <a:p>
             <a:r>
+              <a:rPr sz="1300">
+                <a:latin typeface="Calibri"/>
+              </a:rPr>
               <a:t>   via keyframe CSS spin-slow.</a:t>
             </a:r>
           </a:p>
           <a:p/>
           <a:p>
             <a:r>
+              <a:rPr sz="1300">
+                <a:latin typeface="Calibri"/>
+              </a:rPr>
               <a:t>3. Glow blur di belakang memakai</a:t>
             </a:r>
           </a:p>
           <a:p>
             <a:r>
+              <a:rPr sz="1300">
+                <a:latin typeface="Calibri"/>
+              </a:rPr>
               <a:t>   animate-pulse-soft.</a:t>
             </a:r>
           </a:p>
           <a:p/>
           <a:p>
             <a:r>
+              <a:rPr sz="1300">
+                <a:latin typeface="Calibri"/>
+              </a:rPr>
               <a:t>4. Semua animasi murni CSS,</a:t>
             </a:r>
           </a:p>
           <a:p>
             <a:r>
+              <a:rPr sz="1300">
+                <a:latin typeface="Calibri"/>
+              </a:rPr>
               <a:t>   tanpa library eksternal.</a:t>
             </a:r>
           </a:p>
@@ -5185,99 +5178,7 @@
       <p:grpSpPr/>
       <p:sp>
         <p:nvSpPr>
-          <p:cNvPr id="2" name="Title 1"/>
-          <p:cNvSpPr>
-            <a:spLocks noGrp="1"/>
-          </p:cNvSpPr>
-          <p:nvPr>
-            <p:ph type="title"/>
-          </p:nvPr>
-        </p:nvSpPr>
-        <p:spPr/>
-        <p:txBody>
-          <a:bodyPr/>
-          <a:lstStyle/>
-          <a:p>
-            <a:r>
-              <a:t>Hasil PageSpeed Insights</a:t>
-            </a:r>
-          </a:p>
-        </p:txBody>
-      </p:sp>
-      <p:sp>
-        <p:nvSpPr>
-          <p:cNvPr id="3" name="Content Placeholder 2"/>
-          <p:cNvSpPr>
-            <a:spLocks noGrp="1"/>
-          </p:cNvSpPr>
-          <p:nvPr>
-            <p:ph idx="1"/>
-          </p:nvPr>
-        </p:nvSpPr>
-        <p:spPr/>
-        <p:txBody>
-          <a:bodyPr/>
-          <a:lstStyle/>
-          <a:p>
-            <a:pPr/>
-            <a:r>
-              <a:rPr b="1">
-                <a:solidFill>
-                  <a:srgbClr val="1E293B"/>
-                </a:solidFill>
-              </a:rPr>
-              <a:t>Upaya optimasi yang dilakukan:</a:t>
-            </a:r>
-          </a:p>
-          <a:p>
-            <a:pPr/>
-            <a:r>
-              <a:rPr>
-                <a:solidFill>
-                  <a:srgbClr val="334155"/>
-                </a:solidFill>
-              </a:rPr>
-              <a:t>Build produksi Vite (minify, tree-shaking, code-splitting).</a:t>
-            </a:r>
-          </a:p>
-          <a:p>
-            <a:pPr/>
-            <a:r>
-              <a:rPr>
-                <a:solidFill>
-                  <a:srgbClr val="334155"/>
-                </a:solidFill>
-              </a:rPr>
-              <a:t>CSS dari Tailwind yang otomatis di-purge (ukuran kecil).</a:t>
-            </a:r>
-          </a:p>
-          <a:p>
-            <a:pPr/>
-            <a:r>
-              <a:rPr>
-                <a:solidFill>
-                  <a:srgbClr val="334155"/>
-                </a:solidFill>
-              </a:rPr>
-              <a:t>Avatar &amp; background berbasis CSS/SVG — tanpa bitmap besar (CLS rendah).</a:t>
-            </a:r>
-          </a:p>
-          <a:p>
-            <a:pPr/>
-            <a:r>
-              <a:rPr>
-                <a:solidFill>
-                  <a:srgbClr val="334155"/>
-                </a:solidFill>
-              </a:rPr>
-              <a:t>SPA fallback + robots.txt agar render dan indexing bersih.</a:t>
-            </a:r>
-          </a:p>
-        </p:txBody>
-      </p:sp>
-      <p:sp>
-        <p:nvSpPr>
-          <p:cNvPr id="4" name="Rectangle 3"/>
+          <p:cNvPr id="2" name="Rectangle 1"/>
           <p:cNvSpPr/>
           <p:nvPr/>
         </p:nvSpPr>
@@ -5317,14 +5218,110 @@
       </p:sp>
       <p:sp>
         <p:nvSpPr>
+          <p:cNvPr id="3" name="Rectangle 2"/>
+          <p:cNvSpPr/>
+          <p:nvPr/>
+        </p:nvSpPr>
+        <p:spPr>
+          <a:xfrm>
+            <a:off x="640080" y="457200"/>
+            <a:ext cx="10881360" cy="731520"/>
+          </a:xfrm>
+          <a:prstGeom prst="rect">
+            <a:avLst/>
+          </a:prstGeom>
+          <a:solidFill>
+            <a:srgbClr val="6366F1"/>
+          </a:solidFill>
+        </p:spPr>
+        <p:style>
+          <a:lnRef idx="1">
+            <a:schemeClr val="accent1"/>
+          </a:lnRef>
+          <a:fillRef idx="3">
+            <a:schemeClr val="accent1"/>
+          </a:fillRef>
+          <a:effectRef idx="2">
+            <a:schemeClr val="accent1"/>
+          </a:effectRef>
+          <a:fontRef idx="minor">
+            <a:schemeClr val="lt1"/>
+          </a:fontRef>
+        </p:style>
+        <p:txBody>
+          <a:bodyPr rtlCol="0" anchor="ctr"/>
+          <a:lstStyle/>
+          <a:p>
+            <a:r>
+              <a:rPr sz="2200" b="1">
+                <a:solidFill>
+                  <a:srgbClr val="FFFFFF"/>
+                </a:solidFill>
+                <a:latin typeface="Calibri"/>
+              </a:rPr>
+              <a:t>Hasil PageSpeed Insights</a:t>
+            </a:r>
+          </a:p>
+        </p:txBody>
+      </p:sp>
+      <p:sp>
+        <p:nvSpPr>
+          <p:cNvPr id="4" name="Rounded Rectangle 3"/>
+          <p:cNvSpPr/>
+          <p:nvPr/>
+        </p:nvSpPr>
+        <p:spPr>
+          <a:xfrm>
+            <a:off x="640080" y="1417320"/>
+            <a:ext cx="4937760" cy="457200"/>
+          </a:xfrm>
+          <a:prstGeom prst="roundRect">
+            <a:avLst/>
+          </a:prstGeom>
+          <a:solidFill>
+            <a:srgbClr val="312E81"/>
+          </a:solidFill>
+        </p:spPr>
+        <p:style>
+          <a:lnRef idx="1">
+            <a:schemeClr val="accent1"/>
+          </a:lnRef>
+          <a:fillRef idx="3">
+            <a:schemeClr val="accent1"/>
+          </a:fillRef>
+          <a:effectRef idx="2">
+            <a:schemeClr val="accent1"/>
+          </a:effectRef>
+          <a:fontRef idx="minor">
+            <a:schemeClr val="lt1"/>
+          </a:fontRef>
+        </p:style>
+        <p:txBody>
+          <a:bodyPr rtlCol="0" anchor="ctr"/>
+          <a:lstStyle/>
+          <a:p>
+            <a:r>
+              <a:rPr sz="1600" b="1">
+                <a:solidFill>
+                  <a:srgbClr val="FFFFFF"/>
+                </a:solidFill>
+                <a:latin typeface="Calibri"/>
+              </a:rPr>
+              <a:t>Mobile</a:t>
+            </a:r>
+          </a:p>
+        </p:txBody>
+      </p:sp>
+      <p:sp>
+        <p:nvSpPr>
           <p:cNvPr id="5" name="Rounded Rectangle 4"/>
           <p:cNvSpPr/>
           <p:nvPr/>
         </p:nvSpPr>
         <p:spPr>
           <a:xfrm>
-            <a:off x="731520" y="5440680"/>
-            <a:ext cx="5212080" cy="914400"/>
+            <a:off x="640080" y="1920240"/>
+            <a:ext cx="4937760" cy="3657600"/>
           </a:xfrm>
           <a:prstGeom prst="roundRect">
             <a:avLst/>
@@ -5352,12 +5349,21 @@
           <a:lstStyle/>
           <a:p>
             <a:r>
-              <a:rPr>
+              <a:rPr sz="1600" b="1">
                 <a:solidFill>
                   <a:srgbClr val="4338CA"/>
                 </a:solidFill>
-              </a:rPr>
-              <a:t>Skor Mobile — sisipkan screenshot</a:t>
+                <a:latin typeface="Calibri"/>
+              </a:rPr>
+              <a:t>Screenshot skor Mobile</a:t>
+            </a:r>
+          </a:p>
+          <a:p>
+            <a:r>
+              <a:rPr sz="1600" b="1">
+                <a:latin typeface="Calibri"/>
+              </a:rPr>
+              <a:t>sisipkan di sini</a:t>
             </a:r>
           </a:p>
         </p:txBody>
@@ -5370,8 +5376,56 @@
         </p:nvSpPr>
         <p:spPr>
           <a:xfrm>
-            <a:off x="6263640" y="5440680"/>
-            <a:ext cx="5212080" cy="914400"/>
+            <a:off x="5852160" y="1417320"/>
+            <a:ext cx="5669280" cy="457200"/>
+          </a:xfrm>
+          <a:prstGeom prst="roundRect">
+            <a:avLst/>
+          </a:prstGeom>
+          <a:solidFill>
+            <a:srgbClr val="312E81"/>
+          </a:solidFill>
+        </p:spPr>
+        <p:style>
+          <a:lnRef idx="1">
+            <a:schemeClr val="accent1"/>
+          </a:lnRef>
+          <a:fillRef idx="3">
+            <a:schemeClr val="accent1"/>
+          </a:fillRef>
+          <a:effectRef idx="2">
+            <a:schemeClr val="accent1"/>
+          </a:effectRef>
+          <a:fontRef idx="minor">
+            <a:schemeClr val="lt1"/>
+          </a:fontRef>
+        </p:style>
+        <p:txBody>
+          <a:bodyPr rtlCol="0" anchor="ctr"/>
+          <a:lstStyle/>
+          <a:p>
+            <a:r>
+              <a:rPr sz="1600" b="1">
+                <a:solidFill>
+                  <a:srgbClr val="FFFFFF"/>
+                </a:solidFill>
+                <a:latin typeface="Calibri"/>
+              </a:rPr>
+              <a:t>Desktop</a:t>
+            </a:r>
+          </a:p>
+        </p:txBody>
+      </p:sp>
+      <p:sp>
+        <p:nvSpPr>
+          <p:cNvPr id="7" name="Rounded Rectangle 6"/>
+          <p:cNvSpPr/>
+          <p:nvPr/>
+        </p:nvSpPr>
+        <p:spPr>
+          <a:xfrm>
+            <a:off x="5852160" y="1920240"/>
+            <a:ext cx="5669280" cy="3657600"/>
           </a:xfrm>
           <a:prstGeom prst="roundRect">
             <a:avLst/>
@@ -5399,32 +5453,41 @@
           <a:lstStyle/>
           <a:p>
             <a:r>
-              <a:rPr>
+              <a:rPr sz="1600" b="1">
                 <a:solidFill>
                   <a:srgbClr val="4338CA"/>
                 </a:solidFill>
-              </a:rPr>
-              <a:t>Skor Desktop — sisipkan screenshot</a:t>
-            </a:r>
-          </a:p>
-        </p:txBody>
-      </p:sp>
-      <p:sp>
-        <p:nvSpPr>
-          <p:cNvPr id="7" name="Rectangle 6"/>
+                <a:latin typeface="Calibri"/>
+              </a:rPr>
+              <a:t>Screenshot skor Desktop</a:t>
+            </a:r>
+          </a:p>
+          <a:p>
+            <a:r>
+              <a:rPr sz="1600" b="1">
+                <a:latin typeface="Calibri"/>
+              </a:rPr>
+              <a:t>sisipkan di sini</a:t>
+            </a:r>
+          </a:p>
+        </p:txBody>
+      </p:sp>
+      <p:sp>
+        <p:nvSpPr>
+          <p:cNvPr id="8" name="Rounded Rectangle 7"/>
           <p:cNvSpPr/>
           <p:nvPr/>
         </p:nvSpPr>
         <p:spPr>
           <a:xfrm>
-            <a:off x="731520" y="6446520"/>
-            <a:ext cx="10698480" cy="9144"/>
+            <a:off x="640080" y="5806440"/>
+            <a:ext cx="10881360" cy="777240"/>
           </a:xfrm>
-          <a:prstGeom prst="rect">
+          <a:prstGeom prst="roundRect">
             <a:avLst/>
           </a:prstGeom>
           <a:solidFill>
-            <a:srgbClr val="E2E8F0"/>
+            <a:srgbClr val="F1F5F9"/>
           </a:solidFill>
         </p:spPr>
         <p:style>
@@ -5445,7 +5508,15 @@
           <a:bodyPr rtlCol="0" anchor="ctr"/>
           <a:lstStyle/>
           <a:p>
-            <a:pPr algn="ctr"/>
+            <a:r>
+              <a:rPr sz="1200">
+                <a:solidFill>
+                  <a:srgbClr val="1E293B"/>
+                </a:solidFill>
+                <a:latin typeface="Calibri"/>
+              </a:rPr>
+              <a:t>Optimasi: build Vite (minify + tree-shaking) · CSS Tailwind ter-purge · avatar &amp; background CSS/SVG tanpa bitmap besar (CLS rendah) · SPA fallback + robots.txt</a:t>
+            </a:r>
           </a:p>
         </p:txBody>
       </p:sp>
@@ -5760,10 +5831,11 @@
           <a:lstStyle/>
           <a:p>
             <a:r>
-              <a:rPr>
+              <a:rPr sz="2200" b="1">
                 <a:solidFill>
                   <a:srgbClr val="FFFFFF"/>
                 </a:solidFill>
+                <a:latin typeface="Calibri"/>
               </a:rPr>
               <a:t>Development Module List</a:t>
             </a:r>
@@ -5812,6 +5884,12 @@
           <a:lstStyle/>
           <a:p>
             <a:r>
+              <a:rPr sz="4000" b="1">
+                <a:solidFill>
+                  <a:srgbClr val="FFFFFF"/>
+                </a:solidFill>
+                <a:latin typeface="Calibri"/>
+              </a:rPr>
               <a:t>Terima Kasih</a:t>
             </a:r>
           </a:p>
@@ -5833,21 +5911,45 @@
           <a:lstStyle/>
           <a:p>
             <a:r>
+              <a:rPr sz="1800">
+                <a:solidFill>
+                  <a:srgbClr val="CBD5E1"/>
+                </a:solidFill>
+                <a:latin typeface="Calibri"/>
+              </a:rPr>
               <a:t>davidmuhamad97@gmail.com</a:t>
             </a:r>
           </a:p>
           <a:p>
             <a:r>
+              <a:rPr sz="1800">
+                <a:solidFill>
+                  <a:srgbClr val="CBD5E1"/>
+                </a:solidFill>
+                <a:latin typeface="Calibri"/>
+              </a:rPr>
               <a:t>github.com/davidmuhamad97-ops</a:t>
             </a:r>
           </a:p>
           <a:p>
             <a:r>
+              <a:rPr sz="1800">
+                <a:solidFill>
+                  <a:srgbClr val="CBD5E1"/>
+                </a:solidFill>
+                <a:latin typeface="Calibri"/>
+              </a:rPr>
               <a:t>linkedin.com/in/muhamad-david-8674b2155</a:t>
             </a:r>
           </a:p>
           <a:p>
             <a:r>
+              <a:rPr sz="1800">
+                <a:solidFill>
+                  <a:srgbClr val="CBD5E1"/>
+                </a:solidFill>
+                <a:latin typeface="Calibri"/>
+              </a:rPr>
               <a:t>my-personalweb-swart.vercel.app</a:t>
             </a:r>
           </a:p>

</xml_diff>

<commit_message>
docs: add mobile PageSpeed screenshot to presentation
</commit_message>
<xml_diff>
--- a/presentation/Code-Challenge-2-Presentasi.pptx
+++ b/presentation/Code-Challenge-2-Presentasi.pptx
@@ -5176,9 +5176,33 @@
         <p:nvPr/>
       </p:nvGrpSpPr>
       <p:grpSpPr/>
-      <p:sp>
-        <p:nvSpPr>
-          <p:cNvPr id="2" name="Rectangle 1"/>
+      <p:pic>
+        <p:nvPicPr>
+          <p:cNvPr id="2" name="Picture 1" descr="pagespeed-mobile.jpg"/>
+          <p:cNvPicPr>
+            <a:picLocks noChangeAspect="1"/>
+          </p:cNvPicPr>
+          <p:nvPr/>
+        </p:nvPicPr>
+        <p:blipFill>
+          <a:blip r:embed="rId2"/>
+          <a:stretch>
+            <a:fillRect/>
+          </a:stretch>
+        </p:blipFill>
+        <p:spPr>
+          <a:xfrm>
+            <a:off x="640080" y="1920240"/>
+            <a:ext cx="4937760" cy="2889504"/>
+          </a:xfrm>
+          <a:prstGeom prst="rect">
+            <a:avLst/>
+          </a:prstGeom>
+        </p:spPr>
+      </p:pic>
+      <p:sp>
+        <p:nvSpPr>
+          <p:cNvPr id="3" name="Rectangle 2"/>
           <p:cNvSpPr/>
           <p:nvPr/>
         </p:nvSpPr>
@@ -5218,7 +5242,7 @@
       </p:sp>
       <p:sp>
         <p:nvSpPr>
-          <p:cNvPr id="3" name="Rectangle 2"/>
+          <p:cNvPr id="4" name="Rectangle 3"/>
           <p:cNvSpPr/>
           <p:nvPr/>
         </p:nvSpPr>
@@ -5266,7 +5290,7 @@
       </p:sp>
       <p:sp>
         <p:nvSpPr>
-          <p:cNvPr id="4" name="Rounded Rectangle 3"/>
+          <p:cNvPr id="5" name="Rounded Rectangle 4"/>
           <p:cNvSpPr/>
           <p:nvPr/>
         </p:nvSpPr>
@@ -5308,62 +5332,6 @@
                 <a:latin typeface="Calibri"/>
               </a:rPr>
               <a:t>Mobile</a:t>
-            </a:r>
-          </a:p>
-        </p:txBody>
-      </p:sp>
-      <p:sp>
-        <p:nvSpPr>
-          <p:cNvPr id="5" name="Rounded Rectangle 4"/>
-          <p:cNvSpPr/>
-          <p:nvPr/>
-        </p:nvSpPr>
-        <p:spPr>
-          <a:xfrm>
-            <a:off x="640080" y="1920240"/>
-            <a:ext cx="4937760" cy="3657600"/>
-          </a:xfrm>
-          <a:prstGeom prst="roundRect">
-            <a:avLst/>
-          </a:prstGeom>
-          <a:solidFill>
-            <a:srgbClr val="EEF2FF"/>
-          </a:solidFill>
-        </p:spPr>
-        <p:style>
-          <a:lnRef idx="1">
-            <a:schemeClr val="accent1"/>
-          </a:lnRef>
-          <a:fillRef idx="3">
-            <a:schemeClr val="accent1"/>
-          </a:fillRef>
-          <a:effectRef idx="2">
-            <a:schemeClr val="accent1"/>
-          </a:effectRef>
-          <a:fontRef idx="minor">
-            <a:schemeClr val="lt1"/>
-          </a:fontRef>
-        </p:style>
-        <p:txBody>
-          <a:bodyPr rtlCol="0" anchor="ctr"/>
-          <a:lstStyle/>
-          <a:p>
-            <a:r>
-              <a:rPr sz="1600" b="1">
-                <a:solidFill>
-                  <a:srgbClr val="4338CA"/>
-                </a:solidFill>
-                <a:latin typeface="Calibri"/>
-              </a:rPr>
-              <a:t>Screenshot skor Mobile</a:t>
-            </a:r>
-          </a:p>
-          <a:p>
-            <a:r>
-              <a:rPr sz="1600" b="1">
-                <a:latin typeface="Calibri"/>
-              </a:rPr>
-              <a:t>sisipkan di sini</a:t>
             </a:r>
           </a:p>
         </p:txBody>

</xml_diff>

<commit_message>
docs: add desktop PageSpeed screenshot to presentation
</commit_message>
<xml_diff>
--- a/presentation/Code-Challenge-2-Presentasi.pptx
+++ b/presentation/Code-Challenge-2-Presentasi.pptx
@@ -5200,9 +5200,33 @@
           </a:prstGeom>
         </p:spPr>
       </p:pic>
-      <p:sp>
-        <p:nvSpPr>
-          <p:cNvPr id="3" name="Rectangle 2"/>
+      <p:pic>
+        <p:nvPicPr>
+          <p:cNvPr id="3" name="Picture 2" descr="pagespeed-desktop.jpg"/>
+          <p:cNvPicPr>
+            <a:picLocks noChangeAspect="1"/>
+          </p:cNvPicPr>
+          <p:nvPr/>
+        </p:nvPicPr>
+        <p:blipFill>
+          <a:blip r:embed="rId3"/>
+          <a:stretch>
+            <a:fillRect/>
+          </a:stretch>
+        </p:blipFill>
+        <p:spPr>
+          <a:xfrm>
+            <a:off x="5852160" y="1920240"/>
+            <a:ext cx="5669280" cy="3255264"/>
+          </a:xfrm>
+          <a:prstGeom prst="rect">
+            <a:avLst/>
+          </a:prstGeom>
+        </p:spPr>
+      </p:pic>
+      <p:sp>
+        <p:nvSpPr>
+          <p:cNvPr id="4" name="Rectangle 3"/>
           <p:cNvSpPr/>
           <p:nvPr/>
         </p:nvSpPr>
@@ -5242,7 +5266,7 @@
       </p:sp>
       <p:sp>
         <p:nvSpPr>
-          <p:cNvPr id="4" name="Rectangle 3"/>
+          <p:cNvPr id="5" name="Rectangle 4"/>
           <p:cNvSpPr/>
           <p:nvPr/>
         </p:nvSpPr>
@@ -5290,7 +5314,7 @@
       </p:sp>
       <p:sp>
         <p:nvSpPr>
-          <p:cNvPr id="5" name="Rounded Rectangle 4"/>
+          <p:cNvPr id="6" name="Rounded Rectangle 5"/>
           <p:cNvSpPr/>
           <p:nvPr/>
         </p:nvSpPr>
@@ -5338,7 +5362,7 @@
       </p:sp>
       <p:sp>
         <p:nvSpPr>
-          <p:cNvPr id="6" name="Rounded Rectangle 5"/>
+          <p:cNvPr id="7" name="Rounded Rectangle 6"/>
           <p:cNvSpPr/>
           <p:nvPr/>
         </p:nvSpPr>
@@ -5380,62 +5404,6 @@
                 <a:latin typeface="Calibri"/>
               </a:rPr>
               <a:t>Desktop</a:t>
-            </a:r>
-          </a:p>
-        </p:txBody>
-      </p:sp>
-      <p:sp>
-        <p:nvSpPr>
-          <p:cNvPr id="7" name="Rounded Rectangle 6"/>
-          <p:cNvSpPr/>
-          <p:nvPr/>
-        </p:nvSpPr>
-        <p:spPr>
-          <a:xfrm>
-            <a:off x="5852160" y="1920240"/>
-            <a:ext cx="5669280" cy="3657600"/>
-          </a:xfrm>
-          <a:prstGeom prst="roundRect">
-            <a:avLst/>
-          </a:prstGeom>
-          <a:solidFill>
-            <a:srgbClr val="EEF2FF"/>
-          </a:solidFill>
-        </p:spPr>
-        <p:style>
-          <a:lnRef idx="1">
-            <a:schemeClr val="accent1"/>
-          </a:lnRef>
-          <a:fillRef idx="3">
-            <a:schemeClr val="accent1"/>
-          </a:fillRef>
-          <a:effectRef idx="2">
-            <a:schemeClr val="accent1"/>
-          </a:effectRef>
-          <a:fontRef idx="minor">
-            <a:schemeClr val="lt1"/>
-          </a:fontRef>
-        </p:style>
-        <p:txBody>
-          <a:bodyPr rtlCol="0" anchor="ctr"/>
-          <a:lstStyle/>
-          <a:p>
-            <a:r>
-              <a:rPr sz="1600" b="1">
-                <a:solidFill>
-                  <a:srgbClr val="4338CA"/>
-                </a:solidFill>
-                <a:latin typeface="Calibri"/>
-              </a:rPr>
-              <a:t>Screenshot skor Desktop</a:t>
-            </a:r>
-          </a:p>
-          <a:p>
-            <a:r>
-              <a:rPr sz="1600" b="1">
-                <a:latin typeface="Calibri"/>
-              </a:rPr>
-              <a:t>sisipkan di sini</a:t>
             </a:r>
           </a:p>
         </p:txBody>

</xml_diff>